<commit_message>
Design polish pass: numbered cards with capped height, taller KPI band
https://claude.ai/code/session_0147E4z8FhgGRoQV1z4DyfQL
</commit_message>
<xml_diff>
--- a/.claude/skills/tetp-deck/examples/example-deck.pptx
+++ b/.claude/skills/tetp-deck/examples/example-deck.pptx
@@ -12973,8 +12973,8 @@
         </p:nvSpPr>
         <p:spPr>
           <a:xfrm>
-            <a:off x="3429000" y="2372868"/>
-            <a:ext cx="1977390" cy="1737360"/>
+            <a:off x="3429000" y="2121408"/>
+            <a:ext cx="1977390" cy="2240280"/>
           </a:xfrm>
           <a:prstGeom prst="rect">
             <a:avLst/>
@@ -13017,7 +13017,7 @@
         </p:nvSpPr>
         <p:spPr>
           <a:xfrm>
-            <a:off x="3429000" y="2372868"/>
+            <a:off x="3429000" y="2121408"/>
             <a:ext cx="1977390" cy="41148"/>
           </a:xfrm>
           <a:prstGeom prst="rect">
@@ -13061,8 +13061,8 @@
         </p:nvSpPr>
         <p:spPr>
           <a:xfrm>
-            <a:off x="3557016" y="2500884"/>
-            <a:ext cx="1721358" cy="1481328"/>
+            <a:off x="3557016" y="2249424"/>
+            <a:ext cx="1721358" cy="1984248"/>
           </a:xfrm>
           <a:prstGeom prst="rect">
             <a:avLst/>
@@ -13135,8 +13135,8 @@
         </p:nvSpPr>
         <p:spPr>
           <a:xfrm>
-            <a:off x="5561838" y="2372868"/>
-            <a:ext cx="1977390" cy="1737360"/>
+            <a:off x="5561838" y="2121408"/>
+            <a:ext cx="1977390" cy="2240280"/>
           </a:xfrm>
           <a:prstGeom prst="rect">
             <a:avLst/>
@@ -13179,7 +13179,7 @@
         </p:nvSpPr>
         <p:spPr>
           <a:xfrm>
-            <a:off x="5561838" y="2372868"/>
+            <a:off x="5561838" y="2121408"/>
             <a:ext cx="1977390" cy="41148"/>
           </a:xfrm>
           <a:prstGeom prst="rect">
@@ -13223,8 +13223,8 @@
         </p:nvSpPr>
         <p:spPr>
           <a:xfrm>
-            <a:off x="5689853" y="2500884"/>
-            <a:ext cx="1721358" cy="1481328"/>
+            <a:off x="5689853" y="2249424"/>
+            <a:ext cx="1721358" cy="1984248"/>
           </a:xfrm>
           <a:prstGeom prst="rect">
             <a:avLst/>
@@ -13297,8 +13297,8 @@
         </p:nvSpPr>
         <p:spPr>
           <a:xfrm>
-            <a:off x="7694675" y="2372868"/>
-            <a:ext cx="1977390" cy="1737360"/>
+            <a:off x="7694675" y="2121408"/>
+            <a:ext cx="1977390" cy="2240280"/>
           </a:xfrm>
           <a:prstGeom prst="rect">
             <a:avLst/>
@@ -13341,7 +13341,7 @@
         </p:nvSpPr>
         <p:spPr>
           <a:xfrm>
-            <a:off x="7694675" y="2372868"/>
+            <a:off x="7694675" y="2121408"/>
             <a:ext cx="1977390" cy="41148"/>
           </a:xfrm>
           <a:prstGeom prst="rect">
@@ -13385,8 +13385,8 @@
         </p:nvSpPr>
         <p:spPr>
           <a:xfrm>
-            <a:off x="7822692" y="2500884"/>
-            <a:ext cx="1721358" cy="1481328"/>
+            <a:off x="7822692" y="2249424"/>
+            <a:ext cx="1721358" cy="1984248"/>
           </a:xfrm>
           <a:prstGeom prst="rect">
             <a:avLst/>
@@ -13459,8 +13459,8 @@
         </p:nvSpPr>
         <p:spPr>
           <a:xfrm>
-            <a:off x="9827514" y="2372868"/>
-            <a:ext cx="1977390" cy="1737360"/>
+            <a:off x="9827514" y="2121408"/>
+            <a:ext cx="1977390" cy="2240280"/>
           </a:xfrm>
           <a:prstGeom prst="rect">
             <a:avLst/>
@@ -13503,7 +13503,7 @@
         </p:nvSpPr>
         <p:spPr>
           <a:xfrm>
-            <a:off x="9827514" y="2372868"/>
+            <a:off x="9827514" y="2121408"/>
             <a:ext cx="1977390" cy="41148"/>
           </a:xfrm>
           <a:prstGeom prst="rect">
@@ -13547,8 +13547,8 @@
         </p:nvSpPr>
         <p:spPr>
           <a:xfrm>
-            <a:off x="9955530" y="2500884"/>
-            <a:ext cx="1721358" cy="1481328"/>
+            <a:off x="9955530" y="2249424"/>
+            <a:ext cx="1721358" cy="1984248"/>
           </a:xfrm>
           <a:prstGeom prst="rect">
             <a:avLst/>
@@ -13688,7 +13688,7 @@
         <p:spPr>
           <a:xfrm>
             <a:off x="3429000" y="384048"/>
-            <a:ext cx="2688336" cy="5715000"/>
+            <a:ext cx="2688336" cy="3566160"/>
           </a:xfrm>
           <a:prstGeom prst="rect">
             <a:avLst/>
@@ -13775,8 +13775,8 @@
         </p:nvSpPr>
         <p:spPr>
           <a:xfrm>
-            <a:off x="3557016" y="603504"/>
-            <a:ext cx="2432304" cy="5367528"/>
+            <a:off x="3593592" y="621792"/>
+            <a:ext cx="2359152" cy="3163824"/>
           </a:xfrm>
           <a:prstGeom prst="rect">
             <a:avLst/>
@@ -13793,6 +13793,25 @@
               <a:lnSpc>
                 <a:spcPct val="115000"/>
               </a:lnSpc>
+            </a:pPr>
+            <a:r>
+              <a:rPr sz="1200" b="1">
+                <a:solidFill>
+                  <a:srgbClr val="C4996C"/>
+                </a:solidFill>
+                <a:latin typeface="Arial"/>
+              </a:rPr>
+              <a:t>01</a:t>
+            </a:r>
+          </a:p>
+          <a:p>
+            <a:pPr algn="l">
+              <a:lnSpc>
+                <a:spcPct val="115000"/>
+              </a:lnSpc>
+              <a:spcBef>
+                <a:spcPts val="200"/>
+              </a:spcBef>
             </a:pPr>
             <a:r>
               <a:rPr sz="1300" b="1">
@@ -13810,7 +13829,7 @@
                 <a:spcPct val="115000"/>
               </a:lnSpc>
               <a:spcBef>
-                <a:spcPts val="500"/>
+                <a:spcPts val="600"/>
               </a:spcBef>
             </a:pPr>
             <a:r>
@@ -13834,7 +13853,7 @@
         <p:spPr>
           <a:xfrm>
             <a:off x="6272783" y="384048"/>
-            <a:ext cx="2688336" cy="5715000"/>
+            <a:ext cx="2688336" cy="3566160"/>
           </a:xfrm>
           <a:prstGeom prst="rect">
             <a:avLst/>
@@ -13921,8 +13940,8 @@
         </p:nvSpPr>
         <p:spPr>
           <a:xfrm>
-            <a:off x="6400799" y="603504"/>
-            <a:ext cx="2432304" cy="5367528"/>
+            <a:off x="6437375" y="621792"/>
+            <a:ext cx="2359152" cy="3163824"/>
           </a:xfrm>
           <a:prstGeom prst="rect">
             <a:avLst/>
@@ -13939,6 +13958,25 @@
               <a:lnSpc>
                 <a:spcPct val="115000"/>
               </a:lnSpc>
+            </a:pPr>
+            <a:r>
+              <a:rPr sz="1200" b="1">
+                <a:solidFill>
+                  <a:srgbClr val="C4996C"/>
+                </a:solidFill>
+                <a:latin typeface="Arial"/>
+              </a:rPr>
+              <a:t>02</a:t>
+            </a:r>
+          </a:p>
+          <a:p>
+            <a:pPr algn="l">
+              <a:lnSpc>
+                <a:spcPct val="115000"/>
+              </a:lnSpc>
+              <a:spcBef>
+                <a:spcPts val="200"/>
+              </a:spcBef>
             </a:pPr>
             <a:r>
               <a:rPr sz="1300" b="1">
@@ -13956,7 +13994,7 @@
                 <a:spcPct val="115000"/>
               </a:lnSpc>
               <a:spcBef>
-                <a:spcPts val="500"/>
+                <a:spcPts val="600"/>
               </a:spcBef>
             </a:pPr>
             <a:r>
@@ -13980,7 +14018,7 @@
         <p:spPr>
           <a:xfrm>
             <a:off x="9116567" y="384048"/>
-            <a:ext cx="2688336" cy="5715000"/>
+            <a:ext cx="2688336" cy="3566160"/>
           </a:xfrm>
           <a:prstGeom prst="rect">
             <a:avLst/>
@@ -14067,8 +14105,8 @@
         </p:nvSpPr>
         <p:spPr>
           <a:xfrm>
-            <a:off x="9244584" y="603504"/>
-            <a:ext cx="2432304" cy="5367528"/>
+            <a:off x="9281159" y="621792"/>
+            <a:ext cx="2359152" cy="3163824"/>
           </a:xfrm>
           <a:prstGeom prst="rect">
             <a:avLst/>
@@ -14085,6 +14123,25 @@
               <a:lnSpc>
                 <a:spcPct val="115000"/>
               </a:lnSpc>
+            </a:pPr>
+            <a:r>
+              <a:rPr sz="1200" b="1">
+                <a:solidFill>
+                  <a:srgbClr val="C4996C"/>
+                </a:solidFill>
+                <a:latin typeface="Arial"/>
+              </a:rPr>
+              <a:t>03</a:t>
+            </a:r>
+          </a:p>
+          <a:p>
+            <a:pPr algn="l">
+              <a:lnSpc>
+                <a:spcPct val="115000"/>
+              </a:lnSpc>
+              <a:spcBef>
+                <a:spcPts val="200"/>
+              </a:spcBef>
             </a:pPr>
             <a:r>
               <a:rPr sz="1300" b="1">
@@ -14102,7 +14159,7 @@
                 <a:spcPct val="115000"/>
               </a:lnSpc>
               <a:spcBef>
-                <a:spcPts val="500"/>
+                <a:spcPts val="600"/>
               </a:spcBef>
             </a:pPr>
             <a:r>

</xml_diff>

<commit_message>
Encode TETP house style mined from reference deck; add tracker pattern
- tokens: reference palette (soft navy/deep copper gradient pairs, tan rail
  panel, status color code), denser type scale (10.5pt body, 12pt headings)
- draw: gradient_box, header_bar, hairline cells, chips, status dots + legend
- patterns: gradient header bars (comparison, chart takeaways), gradient
  chevrons, timeline date chips, content-proportioned panel heights
- new tracker pattern: category rail + item/status-dot/progress columns,
  modeled on the reference status slide
- reference .pptx mined in-session only; not committed

https://claude.ai/code/session_0147E4z8FhgGRoQV1z4DyfQL
</commit_message>
<xml_diff>
--- a/.claude/skills/tetp-deck/examples/example-deck.pptx
+++ b/.claude/skills/tetp-deck/examples/example-deck.pptx
@@ -21,6 +21,7 @@
     <p:sldId id="265" r:id="rId6"/>
     <p:sldId id="266" r:id="rId24"/>
     <p:sldId id="267" r:id="rId25"/>
+    <p:sldId id="268" r:id="rId26"/>
   </p:sldIdLst>
   <p:sldSz cx="12192000" cy="6858000"/>
   <p:notesSz cx="7010400" cy="9296400"/>
@@ -1220,7 +1221,7 @@
           <a:lstStyle/>
           <a:p>
             <a:pPr>
-              <a:defRPr sz="950">
+              <a:defRPr sz="900">
                 <a:latin typeface="Arial"/>
               </a:defRPr>
             </a:pPr>
@@ -1253,7 +1254,7 @@
           <a:lstStyle/>
           <a:p>
             <a:pPr>
-              <a:defRPr sz="950">
+              <a:defRPr sz="900">
                 <a:latin typeface="Arial"/>
               </a:defRPr>
             </a:pPr>
@@ -1271,7 +1272,7 @@
         <a:lstStyle/>
         <a:p>
           <a:pPr>
-            <a:defRPr sz="950"/>
+            <a:defRPr sz="900"/>
           </a:pPr>
         </a:p>
       </c:txPr>
@@ -1283,7 +1284,7 @@
     <a:lstStyle/>
     <a:p>
       <a:pPr>
-        <a:defRPr sz="950">
+        <a:defRPr sz="900">
           <a:solidFill>
             <a:srgbClr val="1E1E1E"/>
           </a:solidFill>
@@ -12414,135 +12415,7 @@
       <p:grpSpPr/>
       <p:sp>
         <p:nvSpPr>
-          <p:cNvPr id="2" name="Text Placeholder 1"/>
-          <p:cNvSpPr>
-            <a:spLocks noGrp="1"/>
-          </p:cNvSpPr>
-          <p:nvPr>
-            <p:ph type="body" idx="16" sz="quarter"/>
-          </p:nvPr>
-        </p:nvSpPr>
-        <p:spPr/>
-        <p:txBody>
-          <a:bodyPr/>
-          <a:lstStyle/>
-          <a:p>
-            <a:r>
-              <a:rPr>
-                <a:latin typeface="Arial"/>
-              </a:rPr>
-              <a:t>Top risks</a:t>
-            </a:r>
-          </a:p>
-        </p:txBody>
-      </p:sp>
-      <p:sp>
-        <p:nvSpPr>
-          <p:cNvPr id="3" name="Text Placeholder 2"/>
-          <p:cNvSpPr>
-            <a:spLocks noGrp="1"/>
-          </p:cNvSpPr>
-          <p:nvPr>
-            <p:ph type="body" idx="17" sz="quarter"/>
-          </p:nvPr>
-        </p:nvSpPr>
-        <p:spPr/>
-        <p:txBody>
-          <a:bodyPr/>
-          <a:lstStyle/>
-          <a:p>
-            <a:r>
-              <a:rPr>
-                <a:latin typeface="Arial"/>
-              </a:rPr>
-              <a:t>Mitigations in motion</a:t>
-            </a:r>
-          </a:p>
-        </p:txBody>
-      </p:sp>
-      <p:sp>
-        <p:nvSpPr>
-          <p:cNvPr id="4" name="Content Placeholder 3"/>
-          <p:cNvSpPr>
-            <a:spLocks noGrp="1"/>
-          </p:cNvSpPr>
-          <p:nvPr>
-            <p:ph idx="19" sz="quarter"/>
-          </p:nvPr>
-        </p:nvSpPr>
-        <p:spPr/>
-        <p:txBody>
-          <a:bodyPr/>
-          <a:lstStyle/>
-          <a:p>
-            <a:r>
-              <a:rPr>
-                <a:latin typeface="Arial"/>
-              </a:rPr>
-              <a:t>Instructor pipeline shortfall in FY27</a:t>
-            </a:r>
-          </a:p>
-          <a:p>
-            <a:r>
-              <a:rPr>
-                <a:latin typeface="Arial"/>
-              </a:rPr>
-              <a:t>Legacy contract auto-renews in January</a:t>
-            </a:r>
-          </a:p>
-          <a:p>
-            <a:r>
-              <a:rPr>
-                <a:latin typeface="Arial"/>
-              </a:rPr>
-              <a:t>Content quality drift across academies</a:t>
-            </a:r>
-          </a:p>
-        </p:txBody>
-      </p:sp>
-      <p:sp>
-        <p:nvSpPr>
-          <p:cNvPr id="5" name="Content Placeholder 4"/>
-          <p:cNvSpPr>
-            <a:spLocks noGrp="1"/>
-          </p:cNvSpPr>
-          <p:nvPr>
-            <p:ph idx="20" sz="quarter"/>
-          </p:nvPr>
-        </p:nvSpPr>
-        <p:spPr/>
-        <p:txBody>
-          <a:bodyPr/>
-          <a:lstStyle/>
-          <a:p>
-            <a:r>
-              <a:rPr>
-                <a:latin typeface="Arial"/>
-              </a:rPr>
-              <a:t>Certification wave 2 doubled in size</a:t>
-            </a:r>
-          </a:p>
-          <a:p>
-            <a:r>
-              <a:rPr>
-                <a:latin typeface="Arial"/>
-              </a:rPr>
-              <a:t>Termination notice drafted for legal review</a:t>
-            </a:r>
-          </a:p>
-          <a:p>
-            <a:r>
-              <a:rPr>
-                <a:latin typeface="Arial"/>
-              </a:rPr>
-              <a:t>Shared QA rubric pilots this quarter</a:t>
-            </a:r>
-          </a:p>
-        </p:txBody>
-      </p:sp>
-      <p:sp>
-        <p:nvSpPr>
-          <p:cNvPr id="6" name="Title 5"/>
+          <p:cNvPr id="2" name="Title 1"/>
           <p:cNvSpPr>
             <a:spLocks noGrp="1"/>
           </p:cNvSpPr>
@@ -12559,14 +12432,14 @@
               <a:rPr>
                 <a:latin typeface="Arial"/>
               </a:rPr>
-              <a:t>Risks are manageable if two decisions land on time</a:t>
-            </a:r>
-          </a:p>
-        </p:txBody>
-      </p:sp>
-      <p:sp>
-        <p:nvSpPr>
-          <p:cNvPr id="8" name="Text Placeholder 7"/>
+              <a:t>Delivery setup is on track to support pilot delivery from September</a:t>
+            </a:r>
+          </a:p>
+        </p:txBody>
+      </p:sp>
+      <p:sp>
+        <p:nvSpPr>
+          <p:cNvPr id="4" name="Text Placeholder 3"/>
           <p:cNvSpPr>
             <a:spLocks noGrp="1"/>
           </p:cNvSpPr>
@@ -12583,7 +12456,1605 @@
               <a:rPr>
                 <a:latin typeface="Arial"/>
               </a:rPr>
-              <a:t>Source: TETP risk register (illustrative)</a:t>
+              <a:t>Source: TETP program office (illustrative)</a:t>
+            </a:r>
+          </a:p>
+        </p:txBody>
+      </p:sp>
+      <p:sp>
+        <p:nvSpPr>
+          <p:cNvPr id="5" name="Text Placeholder 4"/>
+          <p:cNvSpPr>
+            <a:spLocks noGrp="1"/>
+          </p:cNvSpPr>
+          <p:nvPr>
+            <p:ph type="body" idx="23" sz="quarter"/>
+          </p:nvPr>
+        </p:nvSpPr>
+        <p:spPr/>
+        <p:txBody>
+          <a:bodyPr/>
+          <a:lstStyle/>
+          <a:p>
+            <a:r>
+              <a:rPr>
+                <a:latin typeface="Arial"/>
+              </a:rPr>
+              <a:t>Workstream status</a:t>
+            </a:r>
+          </a:p>
+        </p:txBody>
+      </p:sp>
+      <p:sp>
+        <p:nvSpPr>
+          <p:cNvPr id="6" name="Rectangle 5"/>
+          <p:cNvSpPr/>
+          <p:nvPr/>
+        </p:nvSpPr>
+        <p:spPr>
+          <a:xfrm>
+            <a:off x="1755648" y="1380744"/>
+            <a:ext cx="3419856" cy="292608"/>
+          </a:xfrm>
+          <a:prstGeom prst="rect">
+            <a:avLst/>
+          </a:prstGeom>
+          <a:gradFill rotWithShape="1">
+            <a:gsLst>
+              <a:gs pos="0">
+                <a:srgbClr val="5D5E92"/>
+              </a:gs>
+              <a:gs pos="100000">
+                <a:srgbClr val="3A3B68"/>
+              </a:gs>
+            </a:gsLst>
+            <a:lin scaled="0" ang="18000000"/>
+          </a:gradFill>
+          <a:ln>
+            <a:noFill/>
+          </a:ln>
+          <a:effectLst/>
+        </p:spPr>
+        <p:style>
+          <a:lnRef idx="1">
+            <a:schemeClr val="accent1"/>
+          </a:lnRef>
+          <a:fillRef idx="3">
+            <a:schemeClr val="accent1"/>
+          </a:fillRef>
+          <a:effectRef idx="2">
+            <a:schemeClr val="accent1"/>
+          </a:effectRef>
+          <a:fontRef idx="minor">
+            <a:schemeClr val="lt1"/>
+          </a:fontRef>
+        </p:style>
+        <p:txBody>
+          <a:bodyPr rtlCol="0" anchor="ctr" wrap="square"/>
+          <a:lstStyle/>
+          <a:p>
+            <a:pPr algn="ctr"/>
+          </a:p>
+        </p:txBody>
+      </p:sp>
+      <p:sp>
+        <p:nvSpPr>
+          <p:cNvPr id="7" name="TextBox 6"/>
+          <p:cNvSpPr txBox="1"/>
+          <p:nvPr/>
+        </p:nvSpPr>
+        <p:spPr>
+          <a:xfrm>
+            <a:off x="1865376" y="1380744"/>
+            <a:ext cx="3200400" cy="292608"/>
+          </a:xfrm>
+          <a:prstGeom prst="rect">
+            <a:avLst/>
+          </a:prstGeom>
+          <a:noFill/>
+        </p:spPr>
+        <p:txBody>
+          <a:bodyPr wrap="square" anchor="ctr" lIns="0" rIns="0" tIns="0" bIns="0">
+            <a:spAutoFit/>
+          </a:bodyPr>
+          <a:lstStyle/>
+          <a:p>
+            <a:pPr algn="ctr">
+              <a:lnSpc>
+                <a:spcPct val="112000"/>
+              </a:lnSpc>
+            </a:pPr>
+            <a:r>
+              <a:rPr sz="1200" b="1">
+                <a:solidFill>
+                  <a:srgbClr val="FFFFFF"/>
+                </a:solidFill>
+                <a:latin typeface="Arial"/>
+              </a:rPr>
+              <a:t>Output</a:t>
+            </a:r>
+          </a:p>
+        </p:txBody>
+      </p:sp>
+      <p:sp>
+        <p:nvSpPr>
+          <p:cNvPr id="8" name="Rectangle 7"/>
+          <p:cNvSpPr/>
+          <p:nvPr/>
+        </p:nvSpPr>
+        <p:spPr>
+          <a:xfrm>
+            <a:off x="5303520" y="1380744"/>
+            <a:ext cx="6510528" cy="292608"/>
+          </a:xfrm>
+          <a:prstGeom prst="rect">
+            <a:avLst/>
+          </a:prstGeom>
+          <a:gradFill rotWithShape="1">
+            <a:gsLst>
+              <a:gs pos="0">
+                <a:srgbClr val="5D5E92"/>
+              </a:gs>
+              <a:gs pos="100000">
+                <a:srgbClr val="3A3B68"/>
+              </a:gs>
+            </a:gsLst>
+            <a:lin scaled="0" ang="18000000"/>
+          </a:gradFill>
+          <a:ln>
+            <a:noFill/>
+          </a:ln>
+          <a:effectLst/>
+        </p:spPr>
+        <p:style>
+          <a:lnRef idx="1">
+            <a:schemeClr val="accent1"/>
+          </a:lnRef>
+          <a:fillRef idx="3">
+            <a:schemeClr val="accent1"/>
+          </a:fillRef>
+          <a:effectRef idx="2">
+            <a:schemeClr val="accent1"/>
+          </a:effectRef>
+          <a:fontRef idx="minor">
+            <a:schemeClr val="lt1"/>
+          </a:fontRef>
+        </p:style>
+        <p:txBody>
+          <a:bodyPr rtlCol="0" anchor="ctr" wrap="square"/>
+          <a:lstStyle/>
+          <a:p>
+            <a:pPr algn="ctr"/>
+          </a:p>
+        </p:txBody>
+      </p:sp>
+      <p:sp>
+        <p:nvSpPr>
+          <p:cNvPr id="9" name="TextBox 8"/>
+          <p:cNvSpPr txBox="1"/>
+          <p:nvPr/>
+        </p:nvSpPr>
+        <p:spPr>
+          <a:xfrm>
+            <a:off x="5413248" y="1380744"/>
+            <a:ext cx="6291072" cy="292608"/>
+          </a:xfrm>
+          <a:prstGeom prst="rect">
+            <a:avLst/>
+          </a:prstGeom>
+          <a:noFill/>
+        </p:spPr>
+        <p:txBody>
+          <a:bodyPr wrap="square" anchor="ctr" lIns="0" rIns="0" tIns="0" bIns="0">
+            <a:spAutoFit/>
+          </a:bodyPr>
+          <a:lstStyle/>
+          <a:p>
+            <a:pPr algn="ctr">
+              <a:lnSpc>
+                <a:spcPct val="112000"/>
+              </a:lnSpc>
+            </a:pPr>
+            <a:r>
+              <a:rPr sz="1200" b="1">
+                <a:solidFill>
+                  <a:srgbClr val="FFFFFF"/>
+                </a:solidFill>
+                <a:latin typeface="Arial"/>
+              </a:rPr>
+              <a:t>Progress Update</a:t>
+            </a:r>
+          </a:p>
+        </p:txBody>
+      </p:sp>
+      <p:sp>
+        <p:nvSpPr>
+          <p:cNvPr id="10" name="Rectangle 9"/>
+          <p:cNvSpPr/>
+          <p:nvPr/>
+        </p:nvSpPr>
+        <p:spPr>
+          <a:xfrm>
+            <a:off x="393192" y="1728216"/>
+            <a:ext cx="1234440" cy="4288536"/>
+          </a:xfrm>
+          <a:prstGeom prst="rect">
+            <a:avLst/>
+          </a:prstGeom>
+          <a:solidFill>
+            <a:srgbClr val="EAE1D6"/>
+          </a:solidFill>
+          <a:ln>
+            <a:noFill/>
+          </a:ln>
+          <a:effectLst/>
+        </p:spPr>
+        <p:style>
+          <a:lnRef idx="1">
+            <a:schemeClr val="accent1"/>
+          </a:lnRef>
+          <a:fillRef idx="3">
+            <a:schemeClr val="accent1"/>
+          </a:fillRef>
+          <a:effectRef idx="2">
+            <a:schemeClr val="accent1"/>
+          </a:effectRef>
+          <a:fontRef idx="minor">
+            <a:schemeClr val="lt1"/>
+          </a:fontRef>
+        </p:style>
+        <p:txBody>
+          <a:bodyPr rtlCol="0" anchor="ctr" wrap="square"/>
+          <a:lstStyle/>
+          <a:p>
+            <a:pPr algn="ctr"/>
+          </a:p>
+        </p:txBody>
+      </p:sp>
+      <p:sp>
+        <p:nvSpPr>
+          <p:cNvPr id="11" name="TextBox 10"/>
+          <p:cNvSpPr txBox="1"/>
+          <p:nvPr/>
+        </p:nvSpPr>
+        <p:spPr>
+          <a:xfrm>
+            <a:off x="466344" y="1728216"/>
+            <a:ext cx="1088136" cy="4288536"/>
+          </a:xfrm>
+          <a:prstGeom prst="rect">
+            <a:avLst/>
+          </a:prstGeom>
+          <a:noFill/>
+        </p:spPr>
+        <p:txBody>
+          <a:bodyPr wrap="square" anchor="ctr" lIns="0" rIns="0" tIns="0" bIns="0">
+            <a:spAutoFit/>
+          </a:bodyPr>
+          <a:lstStyle/>
+          <a:p>
+            <a:pPr algn="ctr">
+              <a:lnSpc>
+                <a:spcPct val="112000"/>
+              </a:lnSpc>
+            </a:pPr>
+            <a:r>
+              <a:rPr sz="1050" b="1">
+                <a:solidFill>
+                  <a:srgbClr val="A87F4E"/>
+                </a:solidFill>
+                <a:latin typeface="Arial"/>
+              </a:rPr>
+              <a:t>Course Delivery Setup</a:t>
+            </a:r>
+          </a:p>
+        </p:txBody>
+      </p:sp>
+      <p:sp>
+        <p:nvSpPr>
+          <p:cNvPr id="12" name="Rectangle 11"/>
+          <p:cNvSpPr/>
+          <p:nvPr/>
+        </p:nvSpPr>
+        <p:spPr>
+          <a:xfrm>
+            <a:off x="1755648" y="1728216"/>
+            <a:ext cx="3419856" cy="755294"/>
+          </a:xfrm>
+          <a:prstGeom prst="rect">
+            <a:avLst/>
+          </a:prstGeom>
+          <a:solidFill>
+            <a:srgbClr val="F7F7FA"/>
+          </a:solidFill>
+          <a:ln>
+            <a:noFill/>
+          </a:ln>
+          <a:effectLst/>
+        </p:spPr>
+        <p:style>
+          <a:lnRef idx="1">
+            <a:schemeClr val="accent1"/>
+          </a:lnRef>
+          <a:fillRef idx="3">
+            <a:schemeClr val="accent1"/>
+          </a:fillRef>
+          <a:effectRef idx="2">
+            <a:schemeClr val="accent1"/>
+          </a:effectRef>
+          <a:fontRef idx="minor">
+            <a:schemeClr val="lt1"/>
+          </a:fontRef>
+        </p:style>
+        <p:txBody>
+          <a:bodyPr rtlCol="0" anchor="ctr" wrap="square"/>
+          <a:lstStyle/>
+          <a:p>
+            <a:pPr algn="ctr"/>
+          </a:p>
+        </p:txBody>
+      </p:sp>
+      <p:sp>
+        <p:nvSpPr>
+          <p:cNvPr id="13" name="TextBox 12"/>
+          <p:cNvSpPr txBox="1"/>
+          <p:nvPr/>
+        </p:nvSpPr>
+        <p:spPr>
+          <a:xfrm>
+            <a:off x="1847088" y="1728216"/>
+            <a:ext cx="3008376" cy="755294"/>
+          </a:xfrm>
+          <a:prstGeom prst="rect">
+            <a:avLst/>
+          </a:prstGeom>
+          <a:noFill/>
+        </p:spPr>
+        <p:txBody>
+          <a:bodyPr wrap="square" anchor="ctr" lIns="0" rIns="0" tIns="0" bIns="0">
+            <a:spAutoFit/>
+          </a:bodyPr>
+          <a:lstStyle/>
+          <a:p>
+            <a:pPr algn="l">
+              <a:lnSpc>
+                <a:spcPct val="112000"/>
+              </a:lnSpc>
+            </a:pPr>
+            <a:r>
+              <a:rPr sz="1050" b="1">
+                <a:solidFill>
+                  <a:srgbClr val="3A3B68"/>
+                </a:solidFill>
+                <a:latin typeface="Arial"/>
+              </a:rPr>
+              <a:t>Conduct student selection</a:t>
+            </a:r>
+          </a:p>
+        </p:txBody>
+      </p:sp>
+      <p:sp>
+        <p:nvSpPr>
+          <p:cNvPr id="14" name="Oval 13"/>
+          <p:cNvSpPr/>
+          <p:nvPr/>
+        </p:nvSpPr>
+        <p:spPr>
+          <a:xfrm>
+            <a:off x="4914900" y="2028139"/>
+            <a:ext cx="155448" cy="155448"/>
+          </a:xfrm>
+          <a:prstGeom prst="ellipse">
+            <a:avLst/>
+          </a:prstGeom>
+          <a:solidFill>
+            <a:srgbClr val="00B050"/>
+          </a:solidFill>
+          <a:ln>
+            <a:noFill/>
+          </a:ln>
+          <a:effectLst/>
+        </p:spPr>
+        <p:style>
+          <a:lnRef idx="1">
+            <a:schemeClr val="accent1"/>
+          </a:lnRef>
+          <a:fillRef idx="3">
+            <a:schemeClr val="accent1"/>
+          </a:fillRef>
+          <a:effectRef idx="2">
+            <a:schemeClr val="accent1"/>
+          </a:effectRef>
+          <a:fontRef idx="minor">
+            <a:schemeClr val="lt1"/>
+          </a:fontRef>
+        </p:style>
+        <p:txBody>
+          <a:bodyPr rtlCol="0" anchor="ctr" wrap="square"/>
+          <a:lstStyle/>
+          <a:p>
+            <a:pPr algn="ctr"/>
+          </a:p>
+        </p:txBody>
+      </p:sp>
+      <p:sp>
+        <p:nvSpPr>
+          <p:cNvPr id="15" name="Rectangle 14"/>
+          <p:cNvSpPr/>
+          <p:nvPr/>
+        </p:nvSpPr>
+        <p:spPr>
+          <a:xfrm>
+            <a:off x="5303520" y="1728216"/>
+            <a:ext cx="6510528" cy="755294"/>
+          </a:xfrm>
+          <a:prstGeom prst="rect">
+            <a:avLst/>
+          </a:prstGeom>
+          <a:solidFill>
+            <a:srgbClr val="FFFFFF"/>
+          </a:solidFill>
+          <a:ln w="9525">
+            <a:solidFill>
+              <a:srgbClr val="D9D9D9"/>
+            </a:solidFill>
+          </a:ln>
+          <a:effectLst/>
+        </p:spPr>
+        <p:style>
+          <a:lnRef idx="1">
+            <a:schemeClr val="accent1"/>
+          </a:lnRef>
+          <a:fillRef idx="3">
+            <a:schemeClr val="accent1"/>
+          </a:fillRef>
+          <a:effectRef idx="2">
+            <a:schemeClr val="accent1"/>
+          </a:effectRef>
+          <a:fontRef idx="minor">
+            <a:schemeClr val="lt1"/>
+          </a:fontRef>
+        </p:style>
+        <p:txBody>
+          <a:bodyPr rtlCol="0" anchor="ctr" wrap="square"/>
+          <a:lstStyle/>
+          <a:p>
+            <a:pPr algn="ctr"/>
+          </a:p>
+        </p:txBody>
+      </p:sp>
+      <p:sp>
+        <p:nvSpPr>
+          <p:cNvPr id="16" name="TextBox 15"/>
+          <p:cNvSpPr txBox="1"/>
+          <p:nvPr/>
+        </p:nvSpPr>
+        <p:spPr>
+          <a:xfrm>
+            <a:off x="5394959" y="1783080"/>
+            <a:ext cx="6327648" cy="645566"/>
+          </a:xfrm>
+          <a:prstGeom prst="rect">
+            <a:avLst/>
+          </a:prstGeom>
+          <a:noFill/>
+        </p:spPr>
+        <p:txBody>
+          <a:bodyPr wrap="square" anchor="ctr" lIns="0" rIns="0" tIns="0" bIns="0">
+            <a:spAutoFit/>
+          </a:bodyPr>
+          <a:lstStyle/>
+          <a:p>
+            <a:pPr algn="l">
+              <a:lnSpc>
+                <a:spcPct val="112000"/>
+              </a:lnSpc>
+            </a:pPr>
+            <a:r>
+              <a:rPr sz="1050" b="0">
+                <a:solidFill>
+                  <a:srgbClr val="1E1E1E"/>
+                </a:solidFill>
+                <a:latin typeface="Arial"/>
+              </a:rPr>
+              <a:t>–  Drafted student selection criteria with service institutes</a:t>
+            </a:r>
+          </a:p>
+        </p:txBody>
+      </p:sp>
+      <p:sp>
+        <p:nvSpPr>
+          <p:cNvPr id="17" name="Rectangle 16"/>
+          <p:cNvSpPr/>
+          <p:nvPr/>
+        </p:nvSpPr>
+        <p:spPr>
+          <a:xfrm>
+            <a:off x="1755648" y="2611526"/>
+            <a:ext cx="3419856" cy="755294"/>
+          </a:xfrm>
+          <a:prstGeom prst="rect">
+            <a:avLst/>
+          </a:prstGeom>
+          <a:solidFill>
+            <a:srgbClr val="F7F7FA"/>
+          </a:solidFill>
+          <a:ln>
+            <a:noFill/>
+          </a:ln>
+          <a:effectLst/>
+        </p:spPr>
+        <p:style>
+          <a:lnRef idx="1">
+            <a:schemeClr val="accent1"/>
+          </a:lnRef>
+          <a:fillRef idx="3">
+            <a:schemeClr val="accent1"/>
+          </a:fillRef>
+          <a:effectRef idx="2">
+            <a:schemeClr val="accent1"/>
+          </a:effectRef>
+          <a:fontRef idx="minor">
+            <a:schemeClr val="lt1"/>
+          </a:fontRef>
+        </p:style>
+        <p:txBody>
+          <a:bodyPr rtlCol="0" anchor="ctr" wrap="square"/>
+          <a:lstStyle/>
+          <a:p>
+            <a:pPr algn="ctr"/>
+          </a:p>
+        </p:txBody>
+      </p:sp>
+      <p:sp>
+        <p:nvSpPr>
+          <p:cNvPr id="18" name="TextBox 17"/>
+          <p:cNvSpPr txBox="1"/>
+          <p:nvPr/>
+        </p:nvSpPr>
+        <p:spPr>
+          <a:xfrm>
+            <a:off x="1847088" y="2611526"/>
+            <a:ext cx="3008376" cy="755294"/>
+          </a:xfrm>
+          <a:prstGeom prst="rect">
+            <a:avLst/>
+          </a:prstGeom>
+          <a:noFill/>
+        </p:spPr>
+        <p:txBody>
+          <a:bodyPr wrap="square" anchor="ctr" lIns="0" rIns="0" tIns="0" bIns="0">
+            <a:spAutoFit/>
+          </a:bodyPr>
+          <a:lstStyle/>
+          <a:p>
+            <a:pPr algn="l">
+              <a:lnSpc>
+                <a:spcPct val="112000"/>
+              </a:lnSpc>
+            </a:pPr>
+            <a:r>
+              <a:rPr sz="1050" b="1">
+                <a:solidFill>
+                  <a:srgbClr val="3A3B68"/>
+                </a:solidFill>
+                <a:latin typeface="Arial"/>
+              </a:rPr>
+              <a:t>Secure approval to launch the pilot courses</a:t>
+            </a:r>
+          </a:p>
+        </p:txBody>
+      </p:sp>
+      <p:sp>
+        <p:nvSpPr>
+          <p:cNvPr id="19" name="Oval 18"/>
+          <p:cNvSpPr/>
+          <p:nvPr/>
+        </p:nvSpPr>
+        <p:spPr>
+          <a:xfrm>
+            <a:off x="4914900" y="2911449"/>
+            <a:ext cx="155448" cy="155448"/>
+          </a:xfrm>
+          <a:prstGeom prst="ellipse">
+            <a:avLst/>
+          </a:prstGeom>
+          <a:solidFill>
+            <a:srgbClr val="00B050"/>
+          </a:solidFill>
+          <a:ln>
+            <a:noFill/>
+          </a:ln>
+          <a:effectLst/>
+        </p:spPr>
+        <p:style>
+          <a:lnRef idx="1">
+            <a:schemeClr val="accent1"/>
+          </a:lnRef>
+          <a:fillRef idx="3">
+            <a:schemeClr val="accent1"/>
+          </a:fillRef>
+          <a:effectRef idx="2">
+            <a:schemeClr val="accent1"/>
+          </a:effectRef>
+          <a:fontRef idx="minor">
+            <a:schemeClr val="lt1"/>
+          </a:fontRef>
+        </p:style>
+        <p:txBody>
+          <a:bodyPr rtlCol="0" anchor="ctr" wrap="square"/>
+          <a:lstStyle/>
+          <a:p>
+            <a:pPr algn="ctr"/>
+          </a:p>
+        </p:txBody>
+      </p:sp>
+      <p:sp>
+        <p:nvSpPr>
+          <p:cNvPr id="20" name="Rectangle 19"/>
+          <p:cNvSpPr/>
+          <p:nvPr/>
+        </p:nvSpPr>
+        <p:spPr>
+          <a:xfrm>
+            <a:off x="5303520" y="2611526"/>
+            <a:ext cx="6510528" cy="755294"/>
+          </a:xfrm>
+          <a:prstGeom prst="rect">
+            <a:avLst/>
+          </a:prstGeom>
+          <a:solidFill>
+            <a:srgbClr val="FFFFFF"/>
+          </a:solidFill>
+          <a:ln w="9525">
+            <a:solidFill>
+              <a:srgbClr val="D9D9D9"/>
+            </a:solidFill>
+          </a:ln>
+          <a:effectLst/>
+        </p:spPr>
+        <p:style>
+          <a:lnRef idx="1">
+            <a:schemeClr val="accent1"/>
+          </a:lnRef>
+          <a:fillRef idx="3">
+            <a:schemeClr val="accent1"/>
+          </a:fillRef>
+          <a:effectRef idx="2">
+            <a:schemeClr val="accent1"/>
+          </a:effectRef>
+          <a:fontRef idx="minor">
+            <a:schemeClr val="lt1"/>
+          </a:fontRef>
+        </p:style>
+        <p:txBody>
+          <a:bodyPr rtlCol="0" anchor="ctr" wrap="square"/>
+          <a:lstStyle/>
+          <a:p>
+            <a:pPr algn="ctr"/>
+          </a:p>
+        </p:txBody>
+      </p:sp>
+      <p:sp>
+        <p:nvSpPr>
+          <p:cNvPr id="21" name="TextBox 20"/>
+          <p:cNvSpPr txBox="1"/>
+          <p:nvPr/>
+        </p:nvSpPr>
+        <p:spPr>
+          <a:xfrm>
+            <a:off x="5394959" y="2666390"/>
+            <a:ext cx="6327648" cy="645566"/>
+          </a:xfrm>
+          <a:prstGeom prst="rect">
+            <a:avLst/>
+          </a:prstGeom>
+          <a:noFill/>
+        </p:spPr>
+        <p:txBody>
+          <a:bodyPr wrap="square" anchor="ctr" lIns="0" rIns="0" tIns="0" bIns="0">
+            <a:spAutoFit/>
+          </a:bodyPr>
+          <a:lstStyle/>
+          <a:p>
+            <a:pPr algn="l">
+              <a:lnSpc>
+                <a:spcPct val="112000"/>
+              </a:lnSpc>
+            </a:pPr>
+            <a:r>
+              <a:rPr sz="1050" b="0">
+                <a:solidFill>
+                  <a:srgbClr val="1E1E1E"/>
+                </a:solidFill>
+                <a:latin typeface="Arial"/>
+              </a:rPr>
+              <a:t>–  Started preparing the Training Authorization Document</a:t>
+            </a:r>
+          </a:p>
+        </p:txBody>
+      </p:sp>
+      <p:sp>
+        <p:nvSpPr>
+          <p:cNvPr id="22" name="Rectangle 21"/>
+          <p:cNvSpPr/>
+          <p:nvPr/>
+        </p:nvSpPr>
+        <p:spPr>
+          <a:xfrm>
+            <a:off x="1755648" y="3494836"/>
+            <a:ext cx="3419856" cy="755294"/>
+          </a:xfrm>
+          <a:prstGeom prst="rect">
+            <a:avLst/>
+          </a:prstGeom>
+          <a:solidFill>
+            <a:srgbClr val="F7F7FA"/>
+          </a:solidFill>
+          <a:ln>
+            <a:noFill/>
+          </a:ln>
+          <a:effectLst/>
+        </p:spPr>
+        <p:style>
+          <a:lnRef idx="1">
+            <a:schemeClr val="accent1"/>
+          </a:lnRef>
+          <a:fillRef idx="3">
+            <a:schemeClr val="accent1"/>
+          </a:fillRef>
+          <a:effectRef idx="2">
+            <a:schemeClr val="accent1"/>
+          </a:effectRef>
+          <a:fontRef idx="minor">
+            <a:schemeClr val="lt1"/>
+          </a:fontRef>
+        </p:style>
+        <p:txBody>
+          <a:bodyPr rtlCol="0" anchor="ctr" wrap="square"/>
+          <a:lstStyle/>
+          <a:p>
+            <a:pPr algn="ctr"/>
+          </a:p>
+        </p:txBody>
+      </p:sp>
+      <p:sp>
+        <p:nvSpPr>
+          <p:cNvPr id="23" name="TextBox 22"/>
+          <p:cNvSpPr txBox="1"/>
+          <p:nvPr/>
+        </p:nvSpPr>
+        <p:spPr>
+          <a:xfrm>
+            <a:off x="1847088" y="3494836"/>
+            <a:ext cx="3008376" cy="755294"/>
+          </a:xfrm>
+          <a:prstGeom prst="rect">
+            <a:avLst/>
+          </a:prstGeom>
+          <a:noFill/>
+        </p:spPr>
+        <p:txBody>
+          <a:bodyPr wrap="square" anchor="ctr" lIns="0" rIns="0" tIns="0" bIns="0">
+            <a:spAutoFit/>
+          </a:bodyPr>
+          <a:lstStyle/>
+          <a:p>
+            <a:pPr algn="l">
+              <a:lnSpc>
+                <a:spcPct val="112000"/>
+              </a:lnSpc>
+            </a:pPr>
+            <a:r>
+              <a:rPr sz="1050" b="1">
+                <a:solidFill>
+                  <a:srgbClr val="3A3B68"/>
+                </a:solidFill>
+                <a:latin typeface="Arial"/>
+              </a:rPr>
+              <a:t>Select instructors for the pilot courses</a:t>
+            </a:r>
+          </a:p>
+        </p:txBody>
+      </p:sp>
+      <p:sp>
+        <p:nvSpPr>
+          <p:cNvPr id="24" name="Oval 23"/>
+          <p:cNvSpPr/>
+          <p:nvPr/>
+        </p:nvSpPr>
+        <p:spPr>
+          <a:xfrm>
+            <a:off x="4914900" y="3794760"/>
+            <a:ext cx="155448" cy="155448"/>
+          </a:xfrm>
+          <a:prstGeom prst="ellipse">
+            <a:avLst/>
+          </a:prstGeom>
+          <a:solidFill>
+            <a:srgbClr val="002060"/>
+          </a:solidFill>
+          <a:ln>
+            <a:noFill/>
+          </a:ln>
+          <a:effectLst/>
+        </p:spPr>
+        <p:style>
+          <a:lnRef idx="1">
+            <a:schemeClr val="accent1"/>
+          </a:lnRef>
+          <a:fillRef idx="3">
+            <a:schemeClr val="accent1"/>
+          </a:fillRef>
+          <a:effectRef idx="2">
+            <a:schemeClr val="accent1"/>
+          </a:effectRef>
+          <a:fontRef idx="minor">
+            <a:schemeClr val="lt1"/>
+          </a:fontRef>
+        </p:style>
+        <p:txBody>
+          <a:bodyPr rtlCol="0" anchor="ctr" wrap="square"/>
+          <a:lstStyle/>
+          <a:p>
+            <a:pPr algn="ctr"/>
+          </a:p>
+        </p:txBody>
+      </p:sp>
+      <p:sp>
+        <p:nvSpPr>
+          <p:cNvPr id="25" name="Rectangle 24"/>
+          <p:cNvSpPr/>
+          <p:nvPr/>
+        </p:nvSpPr>
+        <p:spPr>
+          <a:xfrm>
+            <a:off x="5303520" y="3494836"/>
+            <a:ext cx="6510528" cy="755294"/>
+          </a:xfrm>
+          <a:prstGeom prst="rect">
+            <a:avLst/>
+          </a:prstGeom>
+          <a:solidFill>
+            <a:srgbClr val="FFFFFF"/>
+          </a:solidFill>
+          <a:ln w="9525">
+            <a:solidFill>
+              <a:srgbClr val="D9D9D9"/>
+            </a:solidFill>
+          </a:ln>
+          <a:effectLst/>
+        </p:spPr>
+        <p:style>
+          <a:lnRef idx="1">
+            <a:schemeClr val="accent1"/>
+          </a:lnRef>
+          <a:fillRef idx="3">
+            <a:schemeClr val="accent1"/>
+          </a:fillRef>
+          <a:effectRef idx="2">
+            <a:schemeClr val="accent1"/>
+          </a:effectRef>
+          <a:fontRef idx="minor">
+            <a:schemeClr val="lt1"/>
+          </a:fontRef>
+        </p:style>
+        <p:txBody>
+          <a:bodyPr rtlCol="0" anchor="ctr" wrap="square"/>
+          <a:lstStyle/>
+          <a:p>
+            <a:pPr algn="ctr"/>
+          </a:p>
+        </p:txBody>
+      </p:sp>
+      <p:sp>
+        <p:nvSpPr>
+          <p:cNvPr id="26" name="TextBox 25"/>
+          <p:cNvSpPr txBox="1"/>
+          <p:nvPr/>
+        </p:nvSpPr>
+        <p:spPr>
+          <a:xfrm>
+            <a:off x="5394959" y="3549700"/>
+            <a:ext cx="6327648" cy="645566"/>
+          </a:xfrm>
+          <a:prstGeom prst="rect">
+            <a:avLst/>
+          </a:prstGeom>
+          <a:noFill/>
+        </p:spPr>
+        <p:txBody>
+          <a:bodyPr wrap="square" anchor="ctr" lIns="0" rIns="0" tIns="0" bIns="0">
+            <a:spAutoFit/>
+          </a:bodyPr>
+          <a:lstStyle/>
+          <a:p>
+            <a:pPr algn="l">
+              <a:lnSpc>
+                <a:spcPct val="112000"/>
+              </a:lnSpc>
+            </a:pPr>
+            <a:r>
+              <a:rPr sz="1050" b="0">
+                <a:solidFill>
+                  <a:srgbClr val="1E1E1E"/>
+                </a:solidFill>
+                <a:latin typeface="Arial"/>
+              </a:rPr>
+              <a:t>–  Defined instructor selection criteria; two nominations requested per institute</a:t>
+            </a:r>
+          </a:p>
+        </p:txBody>
+      </p:sp>
+      <p:sp>
+        <p:nvSpPr>
+          <p:cNvPr id="27" name="Rectangle 26"/>
+          <p:cNvSpPr/>
+          <p:nvPr/>
+        </p:nvSpPr>
+        <p:spPr>
+          <a:xfrm>
+            <a:off x="1755648" y="4378147"/>
+            <a:ext cx="3419856" cy="755294"/>
+          </a:xfrm>
+          <a:prstGeom prst="rect">
+            <a:avLst/>
+          </a:prstGeom>
+          <a:solidFill>
+            <a:srgbClr val="F7F7FA"/>
+          </a:solidFill>
+          <a:ln>
+            <a:noFill/>
+          </a:ln>
+          <a:effectLst/>
+        </p:spPr>
+        <p:style>
+          <a:lnRef idx="1">
+            <a:schemeClr val="accent1"/>
+          </a:lnRef>
+          <a:fillRef idx="3">
+            <a:schemeClr val="accent1"/>
+          </a:fillRef>
+          <a:effectRef idx="2">
+            <a:schemeClr val="accent1"/>
+          </a:effectRef>
+          <a:fontRef idx="minor">
+            <a:schemeClr val="lt1"/>
+          </a:fontRef>
+        </p:style>
+        <p:txBody>
+          <a:bodyPr rtlCol="0" anchor="ctr" wrap="square"/>
+          <a:lstStyle/>
+          <a:p>
+            <a:pPr algn="ctr"/>
+          </a:p>
+        </p:txBody>
+      </p:sp>
+      <p:sp>
+        <p:nvSpPr>
+          <p:cNvPr id="28" name="TextBox 27"/>
+          <p:cNvSpPr txBox="1"/>
+          <p:nvPr/>
+        </p:nvSpPr>
+        <p:spPr>
+          <a:xfrm>
+            <a:off x="1847088" y="4378147"/>
+            <a:ext cx="3008376" cy="755294"/>
+          </a:xfrm>
+          <a:prstGeom prst="rect">
+            <a:avLst/>
+          </a:prstGeom>
+          <a:noFill/>
+        </p:spPr>
+        <p:txBody>
+          <a:bodyPr wrap="square" anchor="ctr" lIns="0" rIns="0" tIns="0" bIns="0">
+            <a:spAutoFit/>
+          </a:bodyPr>
+          <a:lstStyle/>
+          <a:p>
+            <a:pPr algn="l">
+              <a:lnSpc>
+                <a:spcPct val="112000"/>
+              </a:lnSpc>
+            </a:pPr>
+            <a:r>
+              <a:rPr sz="1050" b="1">
+                <a:solidFill>
+                  <a:srgbClr val="3A3B68"/>
+                </a:solidFill>
+                <a:latin typeface="Arial"/>
+              </a:rPr>
+              <a:t>Set up LMS and digital course materials</a:t>
+            </a:r>
+          </a:p>
+        </p:txBody>
+      </p:sp>
+      <p:sp>
+        <p:nvSpPr>
+          <p:cNvPr id="29" name="Oval 28"/>
+          <p:cNvSpPr/>
+          <p:nvPr/>
+        </p:nvSpPr>
+        <p:spPr>
+          <a:xfrm>
+            <a:off x="4914900" y="4678070"/>
+            <a:ext cx="155448" cy="155448"/>
+          </a:xfrm>
+          <a:prstGeom prst="ellipse">
+            <a:avLst/>
+          </a:prstGeom>
+          <a:solidFill>
+            <a:srgbClr val="A6A6A6"/>
+          </a:solidFill>
+          <a:ln>
+            <a:noFill/>
+          </a:ln>
+          <a:effectLst/>
+        </p:spPr>
+        <p:style>
+          <a:lnRef idx="1">
+            <a:schemeClr val="accent1"/>
+          </a:lnRef>
+          <a:fillRef idx="3">
+            <a:schemeClr val="accent1"/>
+          </a:fillRef>
+          <a:effectRef idx="2">
+            <a:schemeClr val="accent1"/>
+          </a:effectRef>
+          <a:fontRef idx="minor">
+            <a:schemeClr val="lt1"/>
+          </a:fontRef>
+        </p:style>
+        <p:txBody>
+          <a:bodyPr rtlCol="0" anchor="ctr" wrap="square"/>
+          <a:lstStyle/>
+          <a:p>
+            <a:pPr algn="ctr"/>
+          </a:p>
+        </p:txBody>
+      </p:sp>
+      <p:sp>
+        <p:nvSpPr>
+          <p:cNvPr id="30" name="Rectangle 29"/>
+          <p:cNvSpPr/>
+          <p:nvPr/>
+        </p:nvSpPr>
+        <p:spPr>
+          <a:xfrm>
+            <a:off x="5303520" y="4378147"/>
+            <a:ext cx="6510528" cy="755294"/>
+          </a:xfrm>
+          <a:prstGeom prst="rect">
+            <a:avLst/>
+          </a:prstGeom>
+          <a:solidFill>
+            <a:srgbClr val="FFFFFF"/>
+          </a:solidFill>
+          <a:ln w="9525">
+            <a:solidFill>
+              <a:srgbClr val="D9D9D9"/>
+            </a:solidFill>
+          </a:ln>
+          <a:effectLst/>
+        </p:spPr>
+        <p:style>
+          <a:lnRef idx="1">
+            <a:schemeClr val="accent1"/>
+          </a:lnRef>
+          <a:fillRef idx="3">
+            <a:schemeClr val="accent1"/>
+          </a:fillRef>
+          <a:effectRef idx="2">
+            <a:schemeClr val="accent1"/>
+          </a:effectRef>
+          <a:fontRef idx="minor">
+            <a:schemeClr val="lt1"/>
+          </a:fontRef>
+        </p:style>
+        <p:txBody>
+          <a:bodyPr rtlCol="0" anchor="ctr" wrap="square"/>
+          <a:lstStyle/>
+          <a:p>
+            <a:pPr algn="ctr"/>
+          </a:p>
+        </p:txBody>
+      </p:sp>
+      <p:sp>
+        <p:nvSpPr>
+          <p:cNvPr id="31" name="TextBox 30"/>
+          <p:cNvSpPr txBox="1"/>
+          <p:nvPr/>
+        </p:nvSpPr>
+        <p:spPr>
+          <a:xfrm>
+            <a:off x="5394959" y="4433011"/>
+            <a:ext cx="6327648" cy="645566"/>
+          </a:xfrm>
+          <a:prstGeom prst="rect">
+            <a:avLst/>
+          </a:prstGeom>
+          <a:noFill/>
+        </p:spPr>
+        <p:txBody>
+          <a:bodyPr wrap="square" anchor="ctr" lIns="0" rIns="0" tIns="0" bIns="0">
+            <a:spAutoFit/>
+          </a:bodyPr>
+          <a:lstStyle/>
+          <a:p>
+            <a:pPr algn="l">
+              <a:lnSpc>
+                <a:spcPct val="112000"/>
+              </a:lnSpc>
+            </a:pPr>
+            <a:r>
+              <a:rPr sz="1050" b="0">
+                <a:solidFill>
+                  <a:srgbClr val="1E1E1E"/>
+                </a:solidFill>
+                <a:latin typeface="Arial"/>
+              </a:rPr>
+              <a:t>–  Not started</a:t>
+            </a:r>
+          </a:p>
+        </p:txBody>
+      </p:sp>
+      <p:sp>
+        <p:nvSpPr>
+          <p:cNvPr id="32" name="Rectangle 31"/>
+          <p:cNvSpPr/>
+          <p:nvPr/>
+        </p:nvSpPr>
+        <p:spPr>
+          <a:xfrm>
+            <a:off x="1755648" y="5261457"/>
+            <a:ext cx="3419856" cy="755294"/>
+          </a:xfrm>
+          <a:prstGeom prst="rect">
+            <a:avLst/>
+          </a:prstGeom>
+          <a:solidFill>
+            <a:srgbClr val="F7F7FA"/>
+          </a:solidFill>
+          <a:ln>
+            <a:noFill/>
+          </a:ln>
+          <a:effectLst/>
+        </p:spPr>
+        <p:style>
+          <a:lnRef idx="1">
+            <a:schemeClr val="accent1"/>
+          </a:lnRef>
+          <a:fillRef idx="3">
+            <a:schemeClr val="accent1"/>
+          </a:fillRef>
+          <a:effectRef idx="2">
+            <a:schemeClr val="accent1"/>
+          </a:effectRef>
+          <a:fontRef idx="minor">
+            <a:schemeClr val="lt1"/>
+          </a:fontRef>
+        </p:style>
+        <p:txBody>
+          <a:bodyPr rtlCol="0" anchor="ctr" wrap="square"/>
+          <a:lstStyle/>
+          <a:p>
+            <a:pPr algn="ctr"/>
+          </a:p>
+        </p:txBody>
+      </p:sp>
+      <p:sp>
+        <p:nvSpPr>
+          <p:cNvPr id="33" name="TextBox 32"/>
+          <p:cNvSpPr txBox="1"/>
+          <p:nvPr/>
+        </p:nvSpPr>
+        <p:spPr>
+          <a:xfrm>
+            <a:off x="1847088" y="5261457"/>
+            <a:ext cx="3008376" cy="755294"/>
+          </a:xfrm>
+          <a:prstGeom prst="rect">
+            <a:avLst/>
+          </a:prstGeom>
+          <a:noFill/>
+        </p:spPr>
+        <p:txBody>
+          <a:bodyPr wrap="square" anchor="ctr" lIns="0" rIns="0" tIns="0" bIns="0">
+            <a:spAutoFit/>
+          </a:bodyPr>
+          <a:lstStyle/>
+          <a:p>
+            <a:pPr algn="l">
+              <a:lnSpc>
+                <a:spcPct val="112000"/>
+              </a:lnSpc>
+            </a:pPr>
+            <a:r>
+              <a:rPr sz="1050" b="1">
+                <a:solidFill>
+                  <a:srgbClr val="3A3B68"/>
+                </a:solidFill>
+                <a:latin typeface="Arial"/>
+              </a:rPr>
+              <a:t>Prepare the physical delivery setup</a:t>
+            </a:r>
+          </a:p>
+        </p:txBody>
+      </p:sp>
+      <p:sp>
+        <p:nvSpPr>
+          <p:cNvPr id="34" name="Oval 33"/>
+          <p:cNvSpPr/>
+          <p:nvPr/>
+        </p:nvSpPr>
+        <p:spPr>
+          <a:xfrm>
+            <a:off x="4914900" y="5561380"/>
+            <a:ext cx="155448" cy="155448"/>
+          </a:xfrm>
+          <a:prstGeom prst="ellipse">
+            <a:avLst/>
+          </a:prstGeom>
+          <a:solidFill>
+            <a:srgbClr val="A6A6A6"/>
+          </a:solidFill>
+          <a:ln>
+            <a:noFill/>
+          </a:ln>
+          <a:effectLst/>
+        </p:spPr>
+        <p:style>
+          <a:lnRef idx="1">
+            <a:schemeClr val="accent1"/>
+          </a:lnRef>
+          <a:fillRef idx="3">
+            <a:schemeClr val="accent1"/>
+          </a:fillRef>
+          <a:effectRef idx="2">
+            <a:schemeClr val="accent1"/>
+          </a:effectRef>
+          <a:fontRef idx="minor">
+            <a:schemeClr val="lt1"/>
+          </a:fontRef>
+        </p:style>
+        <p:txBody>
+          <a:bodyPr rtlCol="0" anchor="ctr" wrap="square"/>
+          <a:lstStyle/>
+          <a:p>
+            <a:pPr algn="ctr"/>
+          </a:p>
+        </p:txBody>
+      </p:sp>
+      <p:sp>
+        <p:nvSpPr>
+          <p:cNvPr id="35" name="Rectangle 34"/>
+          <p:cNvSpPr/>
+          <p:nvPr/>
+        </p:nvSpPr>
+        <p:spPr>
+          <a:xfrm>
+            <a:off x="5303520" y="5261457"/>
+            <a:ext cx="6510528" cy="755294"/>
+          </a:xfrm>
+          <a:prstGeom prst="rect">
+            <a:avLst/>
+          </a:prstGeom>
+          <a:solidFill>
+            <a:srgbClr val="FFFFFF"/>
+          </a:solidFill>
+          <a:ln w="9525">
+            <a:solidFill>
+              <a:srgbClr val="D9D9D9"/>
+            </a:solidFill>
+          </a:ln>
+          <a:effectLst/>
+        </p:spPr>
+        <p:style>
+          <a:lnRef idx="1">
+            <a:schemeClr val="accent1"/>
+          </a:lnRef>
+          <a:fillRef idx="3">
+            <a:schemeClr val="accent1"/>
+          </a:fillRef>
+          <a:effectRef idx="2">
+            <a:schemeClr val="accent1"/>
+          </a:effectRef>
+          <a:fontRef idx="minor">
+            <a:schemeClr val="lt1"/>
+          </a:fontRef>
+        </p:style>
+        <p:txBody>
+          <a:bodyPr rtlCol="0" anchor="ctr" wrap="square"/>
+          <a:lstStyle/>
+          <a:p>
+            <a:pPr algn="ctr"/>
+          </a:p>
+        </p:txBody>
+      </p:sp>
+      <p:sp>
+        <p:nvSpPr>
+          <p:cNvPr id="36" name="TextBox 35"/>
+          <p:cNvSpPr txBox="1"/>
+          <p:nvPr/>
+        </p:nvSpPr>
+        <p:spPr>
+          <a:xfrm>
+            <a:off x="5394959" y="5316321"/>
+            <a:ext cx="6327648" cy="645566"/>
+          </a:xfrm>
+          <a:prstGeom prst="rect">
+            <a:avLst/>
+          </a:prstGeom>
+          <a:noFill/>
+        </p:spPr>
+        <p:txBody>
+          <a:bodyPr wrap="square" anchor="ctr" lIns="0" rIns="0" tIns="0" bIns="0">
+            <a:spAutoFit/>
+          </a:bodyPr>
+          <a:lstStyle/>
+          <a:p>
+            <a:pPr algn="l">
+              <a:lnSpc>
+                <a:spcPct val="112000"/>
+              </a:lnSpc>
+            </a:pPr>
+            <a:r>
+              <a:rPr sz="1050" b="0">
+                <a:solidFill>
+                  <a:srgbClr val="1E1E1E"/>
+                </a:solidFill>
+                <a:latin typeface="Arial"/>
+              </a:rPr>
+              <a:t>–  Not started</a:t>
+            </a:r>
+          </a:p>
+        </p:txBody>
+      </p:sp>
+      <p:sp>
+        <p:nvSpPr>
+          <p:cNvPr id="37" name="Oval 36"/>
+          <p:cNvSpPr/>
+          <p:nvPr/>
+        </p:nvSpPr>
+        <p:spPr>
+          <a:xfrm>
+            <a:off x="1773936" y="6172200"/>
+            <a:ext cx="109728" cy="109728"/>
+          </a:xfrm>
+          <a:prstGeom prst="ellipse">
+            <a:avLst/>
+          </a:prstGeom>
+          <a:solidFill>
+            <a:srgbClr val="A6A6A6"/>
+          </a:solidFill>
+          <a:ln>
+            <a:noFill/>
+          </a:ln>
+          <a:effectLst/>
+        </p:spPr>
+        <p:style>
+          <a:lnRef idx="1">
+            <a:schemeClr val="accent1"/>
+          </a:lnRef>
+          <a:fillRef idx="3">
+            <a:schemeClr val="accent1"/>
+          </a:fillRef>
+          <a:effectRef idx="2">
+            <a:schemeClr val="accent1"/>
+          </a:effectRef>
+          <a:fontRef idx="minor">
+            <a:schemeClr val="lt1"/>
+          </a:fontRef>
+        </p:style>
+        <p:txBody>
+          <a:bodyPr rtlCol="0" anchor="ctr" wrap="square"/>
+          <a:lstStyle/>
+          <a:p>
+            <a:pPr algn="ctr"/>
+          </a:p>
+        </p:txBody>
+      </p:sp>
+      <p:sp>
+        <p:nvSpPr>
+          <p:cNvPr id="38" name="TextBox 37"/>
+          <p:cNvSpPr txBox="1"/>
+          <p:nvPr/>
+        </p:nvSpPr>
+        <p:spPr>
+          <a:xfrm>
+            <a:off x="1920240" y="6089904"/>
+            <a:ext cx="1051560" cy="274320"/>
+          </a:xfrm>
+          <a:prstGeom prst="rect">
+            <a:avLst/>
+          </a:prstGeom>
+          <a:noFill/>
+        </p:spPr>
+        <p:txBody>
+          <a:bodyPr wrap="square" anchor="ctr" lIns="0" rIns="0" tIns="0" bIns="0">
+            <a:spAutoFit/>
+          </a:bodyPr>
+          <a:lstStyle/>
+          <a:p>
+            <a:pPr algn="l">
+              <a:lnSpc>
+                <a:spcPct val="112000"/>
+              </a:lnSpc>
+            </a:pPr>
+            <a:r>
+              <a:rPr sz="900" b="0">
+                <a:solidFill>
+                  <a:srgbClr val="6E6E6E"/>
+                </a:solidFill>
+                <a:latin typeface="Arial"/>
+              </a:rPr>
+              <a:t>Not Started</a:t>
+            </a:r>
+          </a:p>
+        </p:txBody>
+      </p:sp>
+      <p:sp>
+        <p:nvSpPr>
+          <p:cNvPr id="39" name="Oval 38"/>
+          <p:cNvSpPr/>
+          <p:nvPr/>
+        </p:nvSpPr>
+        <p:spPr>
+          <a:xfrm>
+            <a:off x="3008376" y="6172200"/>
+            <a:ext cx="109728" cy="109728"/>
+          </a:xfrm>
+          <a:prstGeom prst="ellipse">
+            <a:avLst/>
+          </a:prstGeom>
+          <a:solidFill>
+            <a:srgbClr val="00B050"/>
+          </a:solidFill>
+          <a:ln>
+            <a:noFill/>
+          </a:ln>
+          <a:effectLst/>
+        </p:spPr>
+        <p:style>
+          <a:lnRef idx="1">
+            <a:schemeClr val="accent1"/>
+          </a:lnRef>
+          <a:fillRef idx="3">
+            <a:schemeClr val="accent1"/>
+          </a:fillRef>
+          <a:effectRef idx="2">
+            <a:schemeClr val="accent1"/>
+          </a:effectRef>
+          <a:fontRef idx="minor">
+            <a:schemeClr val="lt1"/>
+          </a:fontRef>
+        </p:style>
+        <p:txBody>
+          <a:bodyPr rtlCol="0" anchor="ctr" wrap="square"/>
+          <a:lstStyle/>
+          <a:p>
+            <a:pPr algn="ctr"/>
+          </a:p>
+        </p:txBody>
+      </p:sp>
+      <p:sp>
+        <p:nvSpPr>
+          <p:cNvPr id="40" name="TextBox 39"/>
+          <p:cNvSpPr txBox="1"/>
+          <p:nvPr/>
+        </p:nvSpPr>
+        <p:spPr>
+          <a:xfrm>
+            <a:off x="3154680" y="6089904"/>
+            <a:ext cx="1051560" cy="274320"/>
+          </a:xfrm>
+          <a:prstGeom prst="rect">
+            <a:avLst/>
+          </a:prstGeom>
+          <a:noFill/>
+        </p:spPr>
+        <p:txBody>
+          <a:bodyPr wrap="square" anchor="ctr" lIns="0" rIns="0" tIns="0" bIns="0">
+            <a:spAutoFit/>
+          </a:bodyPr>
+          <a:lstStyle/>
+          <a:p>
+            <a:pPr algn="l">
+              <a:lnSpc>
+                <a:spcPct val="112000"/>
+              </a:lnSpc>
+            </a:pPr>
+            <a:r>
+              <a:rPr sz="900" b="0">
+                <a:solidFill>
+                  <a:srgbClr val="6E6E6E"/>
+                </a:solidFill>
+                <a:latin typeface="Arial"/>
+              </a:rPr>
+              <a:t>On Track</a:t>
+            </a:r>
+          </a:p>
+        </p:txBody>
+      </p:sp>
+      <p:sp>
+        <p:nvSpPr>
+          <p:cNvPr id="41" name="Oval 40"/>
+          <p:cNvSpPr/>
+          <p:nvPr/>
+        </p:nvSpPr>
+        <p:spPr>
+          <a:xfrm>
+            <a:off x="4242816" y="6172200"/>
+            <a:ext cx="109728" cy="109728"/>
+          </a:xfrm>
+          <a:prstGeom prst="ellipse">
+            <a:avLst/>
+          </a:prstGeom>
+          <a:solidFill>
+            <a:srgbClr val="002060"/>
+          </a:solidFill>
+          <a:ln>
+            <a:noFill/>
+          </a:ln>
+          <a:effectLst/>
+        </p:spPr>
+        <p:style>
+          <a:lnRef idx="1">
+            <a:schemeClr val="accent1"/>
+          </a:lnRef>
+          <a:fillRef idx="3">
+            <a:schemeClr val="accent1"/>
+          </a:fillRef>
+          <a:effectRef idx="2">
+            <a:schemeClr val="accent1"/>
+          </a:effectRef>
+          <a:fontRef idx="minor">
+            <a:schemeClr val="lt1"/>
+          </a:fontRef>
+        </p:style>
+        <p:txBody>
+          <a:bodyPr rtlCol="0" anchor="ctr" wrap="square"/>
+          <a:lstStyle/>
+          <a:p>
+            <a:pPr algn="ctr"/>
+          </a:p>
+        </p:txBody>
+      </p:sp>
+      <p:sp>
+        <p:nvSpPr>
+          <p:cNvPr id="42" name="TextBox 41"/>
+          <p:cNvSpPr txBox="1"/>
+          <p:nvPr/>
+        </p:nvSpPr>
+        <p:spPr>
+          <a:xfrm>
+            <a:off x="4389120" y="6089904"/>
+            <a:ext cx="1051560" cy="274320"/>
+          </a:xfrm>
+          <a:prstGeom prst="rect">
+            <a:avLst/>
+          </a:prstGeom>
+          <a:noFill/>
+        </p:spPr>
+        <p:txBody>
+          <a:bodyPr wrap="square" anchor="ctr" lIns="0" rIns="0" tIns="0" bIns="0">
+            <a:spAutoFit/>
+          </a:bodyPr>
+          <a:lstStyle/>
+          <a:p>
+            <a:pPr algn="l">
+              <a:lnSpc>
+                <a:spcPct val="112000"/>
+              </a:lnSpc>
+            </a:pPr>
+            <a:r>
+              <a:rPr sz="900" b="0">
+                <a:solidFill>
+                  <a:srgbClr val="6E6E6E"/>
+                </a:solidFill>
+                <a:latin typeface="Arial"/>
+              </a:rPr>
+              <a:t>Completed</a:t>
             </a:r>
           </a:p>
         </p:txBody>
@@ -12608,7 +14079,135 @@
       <p:grpSpPr/>
       <p:sp>
         <p:nvSpPr>
-          <p:cNvPr id="2" name="Title 1"/>
+          <p:cNvPr id="2" name="Text Placeholder 1"/>
+          <p:cNvSpPr>
+            <a:spLocks noGrp="1"/>
+          </p:cNvSpPr>
+          <p:nvPr>
+            <p:ph type="body" idx="16" sz="quarter"/>
+          </p:nvPr>
+        </p:nvSpPr>
+        <p:spPr/>
+        <p:txBody>
+          <a:bodyPr/>
+          <a:lstStyle/>
+          <a:p>
+            <a:r>
+              <a:rPr>
+                <a:latin typeface="Arial"/>
+              </a:rPr>
+              <a:t>Top risks</a:t>
+            </a:r>
+          </a:p>
+        </p:txBody>
+      </p:sp>
+      <p:sp>
+        <p:nvSpPr>
+          <p:cNvPr id="3" name="Text Placeholder 2"/>
+          <p:cNvSpPr>
+            <a:spLocks noGrp="1"/>
+          </p:cNvSpPr>
+          <p:nvPr>
+            <p:ph type="body" idx="17" sz="quarter"/>
+          </p:nvPr>
+        </p:nvSpPr>
+        <p:spPr/>
+        <p:txBody>
+          <a:bodyPr/>
+          <a:lstStyle/>
+          <a:p>
+            <a:r>
+              <a:rPr>
+                <a:latin typeface="Arial"/>
+              </a:rPr>
+              <a:t>Mitigations in motion</a:t>
+            </a:r>
+          </a:p>
+        </p:txBody>
+      </p:sp>
+      <p:sp>
+        <p:nvSpPr>
+          <p:cNvPr id="4" name="Content Placeholder 3"/>
+          <p:cNvSpPr>
+            <a:spLocks noGrp="1"/>
+          </p:cNvSpPr>
+          <p:nvPr>
+            <p:ph idx="19" sz="quarter"/>
+          </p:nvPr>
+        </p:nvSpPr>
+        <p:spPr/>
+        <p:txBody>
+          <a:bodyPr/>
+          <a:lstStyle/>
+          <a:p>
+            <a:r>
+              <a:rPr>
+                <a:latin typeface="Arial"/>
+              </a:rPr>
+              <a:t>Instructor pipeline shortfall in FY27</a:t>
+            </a:r>
+          </a:p>
+          <a:p>
+            <a:r>
+              <a:rPr>
+                <a:latin typeface="Arial"/>
+              </a:rPr>
+              <a:t>Legacy contract auto-renews in January</a:t>
+            </a:r>
+          </a:p>
+          <a:p>
+            <a:r>
+              <a:rPr>
+                <a:latin typeface="Arial"/>
+              </a:rPr>
+              <a:t>Content quality drift across academies</a:t>
+            </a:r>
+          </a:p>
+        </p:txBody>
+      </p:sp>
+      <p:sp>
+        <p:nvSpPr>
+          <p:cNvPr id="5" name="Content Placeholder 4"/>
+          <p:cNvSpPr>
+            <a:spLocks noGrp="1"/>
+          </p:cNvSpPr>
+          <p:nvPr>
+            <p:ph idx="20" sz="quarter"/>
+          </p:nvPr>
+        </p:nvSpPr>
+        <p:spPr/>
+        <p:txBody>
+          <a:bodyPr/>
+          <a:lstStyle/>
+          <a:p>
+            <a:r>
+              <a:rPr>
+                <a:latin typeface="Arial"/>
+              </a:rPr>
+              <a:t>Certification wave 2 doubled in size</a:t>
+            </a:r>
+          </a:p>
+          <a:p>
+            <a:r>
+              <a:rPr>
+                <a:latin typeface="Arial"/>
+              </a:rPr>
+              <a:t>Termination notice drafted for legal review</a:t>
+            </a:r>
+          </a:p>
+          <a:p>
+            <a:r>
+              <a:rPr>
+                <a:latin typeface="Arial"/>
+              </a:rPr>
+              <a:t>Shared QA rubric pilots this quarter</a:t>
+            </a:r>
+          </a:p>
+        </p:txBody>
+      </p:sp>
+      <p:sp>
+        <p:nvSpPr>
+          <p:cNvPr id="6" name="Title 5"/>
           <p:cNvSpPr>
             <a:spLocks noGrp="1"/>
           </p:cNvSpPr>
@@ -12625,14 +14224,14 @@
               <a:rPr>
                 <a:latin typeface="Arial"/>
               </a:rPr>
-              <a:t>Ask of the committee: three approvals to keep Phase 2 on schedule</a:t>
-            </a:r>
-          </a:p>
-        </p:txBody>
-      </p:sp>
-      <p:sp>
-        <p:nvSpPr>
-          <p:cNvPr id="4" name="Text Placeholder 3"/>
+              <a:t>Risks are manageable if two decisions land on time</a:t>
+            </a:r>
+          </a:p>
+        </p:txBody>
+      </p:sp>
+      <p:sp>
+        <p:nvSpPr>
+          <p:cNvPr id="8" name="Text Placeholder 7"/>
           <p:cNvSpPr>
             <a:spLocks noGrp="1"/>
           </p:cNvSpPr>
@@ -12649,168 +14248,7 @@
               <a:rPr>
                 <a:latin typeface="Arial"/>
               </a:rPr>
-              <a:t>Source: TETP program office (illustrative)</a:t>
-            </a:r>
-          </a:p>
-        </p:txBody>
-      </p:sp>
-      <p:sp>
-        <p:nvSpPr>
-          <p:cNvPr id="5" name="Text Placeholder 4"/>
-          <p:cNvSpPr>
-            <a:spLocks noGrp="1"/>
-          </p:cNvSpPr>
-          <p:nvPr>
-            <p:ph type="body" idx="23" sz="quarter"/>
-          </p:nvPr>
-        </p:nvSpPr>
-        <p:spPr/>
-        <p:txBody>
-          <a:bodyPr/>
-          <a:lstStyle/>
-          <a:p>
-            <a:r>
-              <a:rPr>
-                <a:latin typeface="Arial"/>
-              </a:rPr>
-              <a:t>Next steps</a:t>
-            </a:r>
-          </a:p>
-        </p:txBody>
-      </p:sp>
-      <p:sp>
-        <p:nvSpPr>
-          <p:cNvPr id="6" name="TextBox 5"/>
-          <p:cNvSpPr txBox="1"/>
-          <p:nvPr/>
-        </p:nvSpPr>
-        <p:spPr>
-          <a:xfrm>
-            <a:off x="393192" y="1380744"/>
-            <a:ext cx="11420856" cy="4983480"/>
-          </a:xfrm>
-          <a:prstGeom prst="rect">
-            <a:avLst/>
-          </a:prstGeom>
-          <a:noFill/>
-        </p:spPr>
-        <p:txBody>
-          <a:bodyPr wrap="square" anchor="t" lIns="0" rIns="0" tIns="0" bIns="0">
-            <a:spAutoFit/>
-          </a:bodyPr>
-          <a:lstStyle/>
-          <a:p>
-            <a:pPr algn="l">
-              <a:lnSpc>
-                <a:spcPct val="115000"/>
-              </a:lnSpc>
-              <a:spcBef>
-                <a:spcPts val="400"/>
-              </a:spcBef>
-            </a:pPr>
-            <a:r>
-              <a:rPr sz="1100" b="0">
-                <a:solidFill>
-                  <a:srgbClr val="1E1E1E"/>
-                </a:solidFill>
-                <a:latin typeface="Arial"/>
-              </a:rPr>
-              <a:t>• Approve the centralized operating model effective Q3 FY26</a:t>
-            </a:r>
-          </a:p>
-          <a:p>
-            <a:pPr algn="l" lvl="1">
-              <a:lnSpc>
-                <a:spcPct val="115000"/>
-              </a:lnSpc>
-              <a:spcBef>
-                <a:spcPts val="400"/>
-              </a:spcBef>
-            </a:pPr>
-            <a:r>
-              <a:rPr sz="1100" b="0">
-                <a:solidFill>
-                  <a:srgbClr val="1E1E1E"/>
-                </a:solidFill>
-                <a:latin typeface="Arial"/>
-              </a:rPr>
-              <a:t>– Consolidates five platform teams into one; saves SAR 4.2M over two years</a:t>
-            </a:r>
-          </a:p>
-          <a:p>
-            <a:pPr algn="l">
-              <a:lnSpc>
-                <a:spcPct val="115000"/>
-              </a:lnSpc>
-              <a:spcBef>
-                <a:spcPts val="400"/>
-              </a:spcBef>
-            </a:pPr>
-            <a:r>
-              <a:rPr sz="1100" b="0">
-                <a:solidFill>
-                  <a:srgbClr val="1E1E1E"/>
-                </a:solidFill>
-                <a:latin typeface="Arial"/>
-              </a:rPr>
-              <a:t>• Commit FY27 scope by December to stay inside the funding window</a:t>
-            </a:r>
-          </a:p>
-          <a:p>
-            <a:pPr algn="l" lvl="1">
-              <a:lnSpc>
-                <a:spcPct val="115000"/>
-              </a:lnSpc>
-              <a:spcBef>
-                <a:spcPts val="400"/>
-              </a:spcBef>
-            </a:pPr>
-            <a:r>
-              <a:rPr sz="1100" b="0">
-                <a:solidFill>
-                  <a:srgbClr val="1E1E1E"/>
-                </a:solidFill>
-                <a:latin typeface="Arial"/>
-              </a:rPr>
-              <a:t>– Unfunded scope defaults to FY28 with materially higher unit costs</a:t>
-            </a:r>
-          </a:p>
-          <a:p>
-            <a:pPr algn="l">
-              <a:lnSpc>
-                <a:spcPct val="115000"/>
-              </a:lnSpc>
-              <a:spcBef>
-                <a:spcPts val="400"/>
-              </a:spcBef>
-            </a:pPr>
-            <a:r>
-              <a:rPr sz="1100" b="0">
-                <a:solidFill>
-                  <a:srgbClr val="1E1E1E"/>
-                </a:solidFill>
-                <a:latin typeface="Arial"/>
-              </a:rPr>
-              <a:t>• Endorse instructor certification wave 2 starting September</a:t>
-            </a:r>
-          </a:p>
-          <a:p>
-            <a:pPr algn="l" lvl="1">
-              <a:lnSpc>
-                <a:spcPct val="115000"/>
-              </a:lnSpc>
-              <a:spcBef>
-                <a:spcPts val="400"/>
-              </a:spcBef>
-            </a:pPr>
-            <a:r>
-              <a:rPr sz="1100" b="0">
-                <a:solidFill>
-                  <a:srgbClr val="1E1E1E"/>
-                </a:solidFill>
-                <a:latin typeface="Arial"/>
-              </a:rPr>
-              <a:t>– 120 instructors certified by year-end closes the capacity gap</a:t>
+              <a:t>Source: TETP risk register (illustrative)</a:t>
             </a:r>
           </a:p>
         </p:txBody>
@@ -12824,6 +14262,233 @@
 </file>
 
 <file path=ppt/slides/slide12.xml><?xml version="1.0" encoding="utf-8"?>
+<p:sld xmlns:a="http://schemas.openxmlformats.org/drawingml/2006/main" xmlns:p="http://schemas.openxmlformats.org/presentationml/2006/main" xmlns:r="http://schemas.openxmlformats.org/officeDocument/2006/relationships">
+  <p:cSld>
+    <p:spTree>
+      <p:nvGrpSpPr>
+        <p:cNvPr id="1" name=""/>
+        <p:cNvGrpSpPr/>
+        <p:nvPr/>
+      </p:nvGrpSpPr>
+      <p:grpSpPr/>
+      <p:sp>
+        <p:nvSpPr>
+          <p:cNvPr id="2" name="Title 1"/>
+          <p:cNvSpPr>
+            <a:spLocks noGrp="1"/>
+          </p:cNvSpPr>
+          <p:nvPr>
+            <p:ph type="title"/>
+          </p:nvPr>
+        </p:nvSpPr>
+        <p:spPr/>
+        <p:txBody>
+          <a:bodyPr/>
+          <a:lstStyle/>
+          <a:p>
+            <a:r>
+              <a:rPr>
+                <a:latin typeface="Arial"/>
+              </a:rPr>
+              <a:t>Ask of the committee: three approvals to keep Phase 2 on schedule</a:t>
+            </a:r>
+          </a:p>
+        </p:txBody>
+      </p:sp>
+      <p:sp>
+        <p:nvSpPr>
+          <p:cNvPr id="4" name="Text Placeholder 3"/>
+          <p:cNvSpPr>
+            <a:spLocks noGrp="1"/>
+          </p:cNvSpPr>
+          <p:nvPr>
+            <p:ph type="body" idx="22" sz="quarter"/>
+          </p:nvPr>
+        </p:nvSpPr>
+        <p:spPr/>
+        <p:txBody>
+          <a:bodyPr/>
+          <a:lstStyle/>
+          <a:p>
+            <a:r>
+              <a:rPr>
+                <a:latin typeface="Arial"/>
+              </a:rPr>
+              <a:t>Source: TETP program office (illustrative)</a:t>
+            </a:r>
+          </a:p>
+        </p:txBody>
+      </p:sp>
+      <p:sp>
+        <p:nvSpPr>
+          <p:cNvPr id="5" name="Text Placeholder 4"/>
+          <p:cNvSpPr>
+            <a:spLocks noGrp="1"/>
+          </p:cNvSpPr>
+          <p:nvPr>
+            <p:ph type="body" idx="23" sz="quarter"/>
+          </p:nvPr>
+        </p:nvSpPr>
+        <p:spPr/>
+        <p:txBody>
+          <a:bodyPr/>
+          <a:lstStyle/>
+          <a:p>
+            <a:r>
+              <a:rPr>
+                <a:latin typeface="Arial"/>
+              </a:rPr>
+              <a:t>Next steps</a:t>
+            </a:r>
+          </a:p>
+        </p:txBody>
+      </p:sp>
+      <p:sp>
+        <p:nvSpPr>
+          <p:cNvPr id="6" name="TextBox 5"/>
+          <p:cNvSpPr txBox="1"/>
+          <p:nvPr/>
+        </p:nvSpPr>
+        <p:spPr>
+          <a:xfrm>
+            <a:off x="393192" y="1380744"/>
+            <a:ext cx="11420856" cy="4983480"/>
+          </a:xfrm>
+          <a:prstGeom prst="rect">
+            <a:avLst/>
+          </a:prstGeom>
+          <a:noFill/>
+        </p:spPr>
+        <p:txBody>
+          <a:bodyPr wrap="square" anchor="t" lIns="0" rIns="0" tIns="0" bIns="0">
+            <a:spAutoFit/>
+          </a:bodyPr>
+          <a:lstStyle/>
+          <a:p>
+            <a:pPr algn="l">
+              <a:lnSpc>
+                <a:spcPct val="112000"/>
+              </a:lnSpc>
+              <a:spcBef>
+                <a:spcPts val="400"/>
+              </a:spcBef>
+            </a:pPr>
+            <a:r>
+              <a:rPr sz="1050" b="0">
+                <a:solidFill>
+                  <a:srgbClr val="1E1E1E"/>
+                </a:solidFill>
+                <a:latin typeface="Arial"/>
+              </a:rPr>
+              <a:t>• Approve the centralized operating model effective Q3 FY26</a:t>
+            </a:r>
+          </a:p>
+          <a:p>
+            <a:pPr algn="l" lvl="1">
+              <a:lnSpc>
+                <a:spcPct val="112000"/>
+              </a:lnSpc>
+              <a:spcBef>
+                <a:spcPts val="400"/>
+              </a:spcBef>
+            </a:pPr>
+            <a:r>
+              <a:rPr sz="1050" b="0">
+                <a:solidFill>
+                  <a:srgbClr val="1E1E1E"/>
+                </a:solidFill>
+                <a:latin typeface="Arial"/>
+              </a:rPr>
+              <a:t>– Consolidates five platform teams into one; saves SAR 4.2M over two years</a:t>
+            </a:r>
+          </a:p>
+          <a:p>
+            <a:pPr algn="l">
+              <a:lnSpc>
+                <a:spcPct val="112000"/>
+              </a:lnSpc>
+              <a:spcBef>
+                <a:spcPts val="400"/>
+              </a:spcBef>
+            </a:pPr>
+            <a:r>
+              <a:rPr sz="1050" b="0">
+                <a:solidFill>
+                  <a:srgbClr val="1E1E1E"/>
+                </a:solidFill>
+                <a:latin typeface="Arial"/>
+              </a:rPr>
+              <a:t>• Commit FY27 scope by December to stay inside the funding window</a:t>
+            </a:r>
+          </a:p>
+          <a:p>
+            <a:pPr algn="l" lvl="1">
+              <a:lnSpc>
+                <a:spcPct val="112000"/>
+              </a:lnSpc>
+              <a:spcBef>
+                <a:spcPts val="400"/>
+              </a:spcBef>
+            </a:pPr>
+            <a:r>
+              <a:rPr sz="1050" b="0">
+                <a:solidFill>
+                  <a:srgbClr val="1E1E1E"/>
+                </a:solidFill>
+                <a:latin typeface="Arial"/>
+              </a:rPr>
+              <a:t>– Unfunded scope defaults to FY28 with materially higher unit costs</a:t>
+            </a:r>
+          </a:p>
+          <a:p>
+            <a:pPr algn="l">
+              <a:lnSpc>
+                <a:spcPct val="112000"/>
+              </a:lnSpc>
+              <a:spcBef>
+                <a:spcPts val="400"/>
+              </a:spcBef>
+            </a:pPr>
+            <a:r>
+              <a:rPr sz="1050" b="0">
+                <a:solidFill>
+                  <a:srgbClr val="1E1E1E"/>
+                </a:solidFill>
+                <a:latin typeface="Arial"/>
+              </a:rPr>
+              <a:t>• Endorse instructor certification wave 2 starting September</a:t>
+            </a:r>
+          </a:p>
+          <a:p>
+            <a:pPr algn="l" lvl="1">
+              <a:lnSpc>
+                <a:spcPct val="112000"/>
+              </a:lnSpc>
+              <a:spcBef>
+                <a:spcPts val="400"/>
+              </a:spcBef>
+            </a:pPr>
+            <a:r>
+              <a:rPr sz="1050" b="0">
+                <a:solidFill>
+                  <a:srgbClr val="1E1E1E"/>
+                </a:solidFill>
+                <a:latin typeface="Arial"/>
+              </a:rPr>
+              <a:t>– 120 instructors certified by year-end closes the capacity gap</a:t>
+            </a:r>
+          </a:p>
+        </p:txBody>
+      </p:sp>
+    </p:spTree>
+  </p:cSld>
+  <p:clrMapOvr>
+    <a:masterClrMapping/>
+  </p:clrMapOvr>
+</p:sld>
+</file>
+
+<file path=ppt/slides/slide13.xml><?xml version="1.0" encoding="utf-8"?>
 <p:sld xmlns:a="http://schemas.openxmlformats.org/drawingml/2006/main" xmlns:p="http://schemas.openxmlformats.org/presentationml/2006/main" xmlns:r="http://schemas.openxmlformats.org/officeDocument/2006/relationships">
   <p:cSld>
     <p:spTree>
@@ -12974,7 +14639,7 @@
         <p:spPr>
           <a:xfrm>
             <a:off x="3429000" y="2121408"/>
-            <a:ext cx="1977390" cy="2240280"/>
+            <a:ext cx="1997964" cy="2240280"/>
           </a:xfrm>
           <a:prstGeom prst="rect">
             <a:avLst/>
@@ -12982,8 +14647,10 @@
           <a:solidFill>
             <a:srgbClr val="FFFFFF"/>
           </a:solidFill>
-          <a:ln>
-            <a:noFill/>
+          <a:ln w="9525">
+            <a:solidFill>
+              <a:srgbClr val="D9D9D9"/>
+            </a:solidFill>
           </a:ln>
           <a:effectLst/>
         </p:spPr>
@@ -13018,7 +14685,7 @@
         <p:spPr>
           <a:xfrm>
             <a:off x="3429000" y="2121408"/>
-            <a:ext cx="1977390" cy="41148"/>
+            <a:ext cx="1997964" cy="41148"/>
           </a:xfrm>
           <a:prstGeom prst="rect">
             <a:avLst/>
@@ -13061,8 +14728,8 @@
         </p:nvSpPr>
         <p:spPr>
           <a:xfrm>
-            <a:off x="3557016" y="2249424"/>
-            <a:ext cx="1721358" cy="1984248"/>
+            <a:off x="3538728" y="2231136"/>
+            <a:ext cx="1778508" cy="2020824"/>
           </a:xfrm>
           <a:prstGeom prst="rect">
             <a:avLst/>
@@ -13077,11 +14744,11 @@
           <a:p>
             <a:pPr algn="ctr">
               <a:lnSpc>
-                <a:spcPct val="115000"/>
+                <a:spcPct val="112000"/>
               </a:lnSpc>
             </a:pPr>
             <a:r>
-              <a:rPr sz="3600" b="1">
+              <a:rPr sz="3200" b="1">
                 <a:solidFill>
                   <a:srgbClr val="3A3B68"/>
                 </a:solidFill>
@@ -13093,11 +14760,11 @@
           <a:p>
             <a:pPr algn="ctr">
               <a:lnSpc>
-                <a:spcPct val="115000"/>
+                <a:spcPct val="112000"/>
               </a:lnSpc>
             </a:pPr>
             <a:r>
-              <a:rPr sz="950" b="0">
+              <a:rPr sz="900" b="0">
                 <a:solidFill>
                   <a:srgbClr val="6E6E6E"/>
                 </a:solidFill>
@@ -13109,14 +14776,14 @@
           <a:p>
             <a:pPr algn="ctr">
               <a:lnSpc>
-                <a:spcPct val="115000"/>
+                <a:spcPct val="112000"/>
               </a:lnSpc>
               <a:spcBef>
                 <a:spcPts val="400"/>
               </a:spcBef>
             </a:pPr>
             <a:r>
-              <a:rPr sz="1100" b="0">
+              <a:rPr sz="1050" b="0">
                 <a:solidFill>
                   <a:srgbClr val="1E1E1E"/>
                 </a:solidFill>
@@ -13135,8 +14802,8 @@
         </p:nvSpPr>
         <p:spPr>
           <a:xfrm>
-            <a:off x="5561838" y="2121408"/>
-            <a:ext cx="1977390" cy="2240280"/>
+            <a:off x="5554980" y="2121408"/>
+            <a:ext cx="1997964" cy="2240280"/>
           </a:xfrm>
           <a:prstGeom prst="rect">
             <a:avLst/>
@@ -13144,8 +14811,10 @@
           <a:solidFill>
             <a:srgbClr val="FFFFFF"/>
           </a:solidFill>
-          <a:ln>
-            <a:noFill/>
+          <a:ln w="9525">
+            <a:solidFill>
+              <a:srgbClr val="D9D9D9"/>
+            </a:solidFill>
           </a:ln>
           <a:effectLst/>
         </p:spPr>
@@ -13179,8 +14848,8 @@
         </p:nvSpPr>
         <p:spPr>
           <a:xfrm>
-            <a:off x="5561838" y="2121408"/>
-            <a:ext cx="1977390" cy="41148"/>
+            <a:off x="5554980" y="2121408"/>
+            <a:ext cx="1997964" cy="41148"/>
           </a:xfrm>
           <a:prstGeom prst="rect">
             <a:avLst/>
@@ -13223,8 +14892,8 @@
         </p:nvSpPr>
         <p:spPr>
           <a:xfrm>
-            <a:off x="5689853" y="2249424"/>
-            <a:ext cx="1721358" cy="1984248"/>
+            <a:off x="5664708" y="2231136"/>
+            <a:ext cx="1778508" cy="2020824"/>
           </a:xfrm>
           <a:prstGeom prst="rect">
             <a:avLst/>
@@ -13239,11 +14908,11 @@
           <a:p>
             <a:pPr algn="ctr">
               <a:lnSpc>
-                <a:spcPct val="115000"/>
+                <a:spcPct val="112000"/>
               </a:lnSpc>
             </a:pPr>
             <a:r>
-              <a:rPr sz="3600" b="1">
+              <a:rPr sz="3200" b="1">
                 <a:solidFill>
                   <a:srgbClr val="3A3B68"/>
                 </a:solidFill>
@@ -13255,11 +14924,11 @@
           <a:p>
             <a:pPr algn="ctr">
               <a:lnSpc>
-                <a:spcPct val="115000"/>
+                <a:spcPct val="112000"/>
               </a:lnSpc>
             </a:pPr>
             <a:r>
-              <a:rPr sz="950" b="0">
+              <a:rPr sz="900" b="0">
                 <a:solidFill>
                   <a:srgbClr val="6E6E6E"/>
                 </a:solidFill>
@@ -13271,14 +14940,14 @@
           <a:p>
             <a:pPr algn="ctr">
               <a:lnSpc>
-                <a:spcPct val="115000"/>
+                <a:spcPct val="112000"/>
               </a:lnSpc>
               <a:spcBef>
                 <a:spcPts val="400"/>
               </a:spcBef>
             </a:pPr>
             <a:r>
-              <a:rPr sz="1100" b="0">
+              <a:rPr sz="1050" b="0">
                 <a:solidFill>
                   <a:srgbClr val="1E1E1E"/>
                 </a:solidFill>
@@ -13297,8 +14966,8 @@
         </p:nvSpPr>
         <p:spPr>
           <a:xfrm>
-            <a:off x="7694675" y="2121408"/>
-            <a:ext cx="1977390" cy="2240280"/>
+            <a:off x="7680960" y="2121408"/>
+            <a:ext cx="1997964" cy="2240280"/>
           </a:xfrm>
           <a:prstGeom prst="rect">
             <a:avLst/>
@@ -13306,8 +14975,10 @@
           <a:solidFill>
             <a:srgbClr val="FFFFFF"/>
           </a:solidFill>
-          <a:ln>
-            <a:noFill/>
+          <a:ln w="9525">
+            <a:solidFill>
+              <a:srgbClr val="D9D9D9"/>
+            </a:solidFill>
           </a:ln>
           <a:effectLst/>
         </p:spPr>
@@ -13341,8 +15012,8 @@
         </p:nvSpPr>
         <p:spPr>
           <a:xfrm>
-            <a:off x="7694675" y="2121408"/>
-            <a:ext cx="1977390" cy="41148"/>
+            <a:off x="7680960" y="2121408"/>
+            <a:ext cx="1997964" cy="41148"/>
           </a:xfrm>
           <a:prstGeom prst="rect">
             <a:avLst/>
@@ -13385,8 +15056,8 @@
         </p:nvSpPr>
         <p:spPr>
           <a:xfrm>
-            <a:off x="7822692" y="2249424"/>
-            <a:ext cx="1721358" cy="1984248"/>
+            <a:off x="7790688" y="2231136"/>
+            <a:ext cx="1778508" cy="2020824"/>
           </a:xfrm>
           <a:prstGeom prst="rect">
             <a:avLst/>
@@ -13401,11 +15072,11 @@
           <a:p>
             <a:pPr algn="ctr">
               <a:lnSpc>
-                <a:spcPct val="115000"/>
+                <a:spcPct val="112000"/>
               </a:lnSpc>
             </a:pPr>
             <a:r>
-              <a:rPr sz="3600" b="1">
+              <a:rPr sz="3200" b="1">
                 <a:solidFill>
                   <a:srgbClr val="3A3B68"/>
                 </a:solidFill>
@@ -13417,11 +15088,11 @@
           <a:p>
             <a:pPr algn="ctr">
               <a:lnSpc>
-                <a:spcPct val="115000"/>
+                <a:spcPct val="112000"/>
               </a:lnSpc>
             </a:pPr>
             <a:r>
-              <a:rPr sz="950" b="0">
+              <a:rPr sz="900" b="0">
                 <a:solidFill>
                   <a:srgbClr val="6E6E6E"/>
                 </a:solidFill>
@@ -13433,14 +15104,14 @@
           <a:p>
             <a:pPr algn="ctr">
               <a:lnSpc>
-                <a:spcPct val="115000"/>
+                <a:spcPct val="112000"/>
               </a:lnSpc>
               <a:spcBef>
                 <a:spcPts val="400"/>
               </a:spcBef>
             </a:pPr>
             <a:r>
-              <a:rPr sz="1100" b="0">
+              <a:rPr sz="1050" b="0">
                 <a:solidFill>
                   <a:srgbClr val="1E1E1E"/>
                 </a:solidFill>
@@ -13459,8 +15130,8 @@
         </p:nvSpPr>
         <p:spPr>
           <a:xfrm>
-            <a:off x="9827514" y="2121408"/>
-            <a:ext cx="1977390" cy="2240280"/>
+            <a:off x="9806940" y="2121408"/>
+            <a:ext cx="1997964" cy="2240280"/>
           </a:xfrm>
           <a:prstGeom prst="rect">
             <a:avLst/>
@@ -13468,8 +15139,10 @@
           <a:solidFill>
             <a:srgbClr val="FFFFFF"/>
           </a:solidFill>
-          <a:ln>
-            <a:noFill/>
+          <a:ln w="9525">
+            <a:solidFill>
+              <a:srgbClr val="D9D9D9"/>
+            </a:solidFill>
           </a:ln>
           <a:effectLst/>
         </p:spPr>
@@ -13503,8 +15176,8 @@
         </p:nvSpPr>
         <p:spPr>
           <a:xfrm>
-            <a:off x="9827514" y="2121408"/>
-            <a:ext cx="1977390" cy="41148"/>
+            <a:off x="9806940" y="2121408"/>
+            <a:ext cx="1997964" cy="41148"/>
           </a:xfrm>
           <a:prstGeom prst="rect">
             <a:avLst/>
@@ -13547,8 +15220,8 @@
         </p:nvSpPr>
         <p:spPr>
           <a:xfrm>
-            <a:off x="9955530" y="2249424"/>
-            <a:ext cx="1721358" cy="1984248"/>
+            <a:off x="9916668" y="2231136"/>
+            <a:ext cx="1778508" cy="2020824"/>
           </a:xfrm>
           <a:prstGeom prst="rect">
             <a:avLst/>
@@ -13563,7 +15236,7 @@
           <a:p>
             <a:pPr algn="ctr">
               <a:lnSpc>
-                <a:spcPct val="115000"/>
+                <a:spcPct val="112000"/>
               </a:lnSpc>
             </a:pPr>
             <a:r>
@@ -13579,11 +15252,11 @@
           <a:p>
             <a:pPr algn="ctr">
               <a:lnSpc>
-                <a:spcPct val="115000"/>
+                <a:spcPct val="112000"/>
               </a:lnSpc>
             </a:pPr>
             <a:r>
-              <a:rPr sz="950" b="0">
+              <a:rPr sz="900" b="0">
                 <a:solidFill>
                   <a:srgbClr val="6E6E6E"/>
                 </a:solidFill>
@@ -13595,14 +15268,14 @@
           <a:p>
             <a:pPr algn="ctr">
               <a:lnSpc>
-                <a:spcPct val="115000"/>
+                <a:spcPct val="112000"/>
               </a:lnSpc>
               <a:spcBef>
                 <a:spcPts val="400"/>
               </a:spcBef>
             </a:pPr>
             <a:r>
-              <a:rPr sz="1100" b="0">
+              <a:rPr sz="1050" b="0">
                 <a:solidFill>
                   <a:srgbClr val="1E1E1E"/>
                 </a:solidFill>
@@ -13688,7 +15361,7 @@
         <p:spPr>
           <a:xfrm>
             <a:off x="3429000" y="384048"/>
-            <a:ext cx="2688336" cy="3566160"/>
+            <a:ext cx="2706624" cy="3566160"/>
           </a:xfrm>
           <a:prstGeom prst="rect">
             <a:avLst/>
@@ -13696,8 +15369,10 @@
           <a:solidFill>
             <a:srgbClr val="FFFFFF"/>
           </a:solidFill>
-          <a:ln>
-            <a:noFill/>
+          <a:ln w="9525">
+            <a:solidFill>
+              <a:srgbClr val="D9D9D9"/>
+            </a:solidFill>
           </a:ln>
           <a:effectLst/>
         </p:spPr>
@@ -13732,7 +15407,7 @@
         <p:spPr>
           <a:xfrm>
             <a:off x="3429000" y="384048"/>
-            <a:ext cx="2688336" cy="41148"/>
+            <a:ext cx="2706624" cy="41148"/>
           </a:xfrm>
           <a:prstGeom prst="rect">
             <a:avLst/>
@@ -13775,8 +15450,8 @@
         </p:nvSpPr>
         <p:spPr>
           <a:xfrm>
-            <a:off x="3593592" y="621792"/>
-            <a:ext cx="2359152" cy="3163824"/>
+            <a:off x="3575304" y="603503"/>
+            <a:ext cx="2414016" cy="3200400"/>
           </a:xfrm>
           <a:prstGeom prst="rect">
             <a:avLst/>
@@ -13791,7 +15466,7 @@
           <a:p>
             <a:pPr algn="l">
               <a:lnSpc>
-                <a:spcPct val="115000"/>
+                <a:spcPct val="112000"/>
               </a:lnSpc>
             </a:pPr>
             <a:r>
@@ -13807,14 +15482,14 @@
           <a:p>
             <a:pPr algn="l">
               <a:lnSpc>
-                <a:spcPct val="115000"/>
+                <a:spcPct val="112000"/>
               </a:lnSpc>
               <a:spcBef>
                 <a:spcPts val="200"/>
               </a:spcBef>
             </a:pPr>
             <a:r>
-              <a:rPr sz="1300" b="1">
+              <a:rPr sz="1200" b="1">
                 <a:solidFill>
                   <a:srgbClr val="3A3B68"/>
                 </a:solidFill>
@@ -13826,14 +15501,14 @@
           <a:p>
             <a:pPr algn="l">
               <a:lnSpc>
-                <a:spcPct val="115000"/>
+                <a:spcPct val="112000"/>
               </a:lnSpc>
               <a:spcBef>
                 <a:spcPts val="600"/>
               </a:spcBef>
             </a:pPr>
             <a:r>
-              <a:rPr sz="1100" b="0">
+              <a:rPr sz="1050" b="0">
                 <a:solidFill>
                   <a:srgbClr val="1E1E1E"/>
                 </a:solidFill>
@@ -13852,8 +15527,8 @@
         </p:nvSpPr>
         <p:spPr>
           <a:xfrm>
-            <a:off x="6272783" y="384048"/>
-            <a:ext cx="2688336" cy="3566160"/>
+            <a:off x="6263640" y="384048"/>
+            <a:ext cx="2706624" cy="3566160"/>
           </a:xfrm>
           <a:prstGeom prst="rect">
             <a:avLst/>
@@ -13861,8 +15536,10 @@
           <a:solidFill>
             <a:srgbClr val="FFFFFF"/>
           </a:solidFill>
-          <a:ln>
-            <a:noFill/>
+          <a:ln w="9525">
+            <a:solidFill>
+              <a:srgbClr val="D9D9D9"/>
+            </a:solidFill>
           </a:ln>
           <a:effectLst/>
         </p:spPr>
@@ -13896,8 +15573,8 @@
         </p:nvSpPr>
         <p:spPr>
           <a:xfrm>
-            <a:off x="6272783" y="384048"/>
-            <a:ext cx="2688336" cy="41148"/>
+            <a:off x="6263640" y="384048"/>
+            <a:ext cx="2706624" cy="41148"/>
           </a:xfrm>
           <a:prstGeom prst="rect">
             <a:avLst/>
@@ -13940,8 +15617,8 @@
         </p:nvSpPr>
         <p:spPr>
           <a:xfrm>
-            <a:off x="6437375" y="621792"/>
-            <a:ext cx="2359152" cy="3163824"/>
+            <a:off x="6409944" y="603503"/>
+            <a:ext cx="2414016" cy="3200400"/>
           </a:xfrm>
           <a:prstGeom prst="rect">
             <a:avLst/>
@@ -13956,7 +15633,7 @@
           <a:p>
             <a:pPr algn="l">
               <a:lnSpc>
-                <a:spcPct val="115000"/>
+                <a:spcPct val="112000"/>
               </a:lnSpc>
             </a:pPr>
             <a:r>
@@ -13972,14 +15649,14 @@
           <a:p>
             <a:pPr algn="l">
               <a:lnSpc>
-                <a:spcPct val="115000"/>
+                <a:spcPct val="112000"/>
               </a:lnSpc>
               <a:spcBef>
                 <a:spcPts val="200"/>
               </a:spcBef>
             </a:pPr>
             <a:r>
-              <a:rPr sz="1300" b="1">
+              <a:rPr sz="1200" b="1">
                 <a:solidFill>
                   <a:srgbClr val="3A3B68"/>
                 </a:solidFill>
@@ -13991,14 +15668,14 @@
           <a:p>
             <a:pPr algn="l">
               <a:lnSpc>
-                <a:spcPct val="115000"/>
+                <a:spcPct val="112000"/>
               </a:lnSpc>
               <a:spcBef>
                 <a:spcPts val="600"/>
               </a:spcBef>
             </a:pPr>
             <a:r>
-              <a:rPr sz="1100" b="0">
+              <a:rPr sz="1050" b="0">
                 <a:solidFill>
                   <a:srgbClr val="1E1E1E"/>
                 </a:solidFill>
@@ -14017,8 +15694,8 @@
         </p:nvSpPr>
         <p:spPr>
           <a:xfrm>
-            <a:off x="9116567" y="384048"/>
-            <a:ext cx="2688336" cy="3566160"/>
+            <a:off x="9098280" y="384048"/>
+            <a:ext cx="2706624" cy="3566160"/>
           </a:xfrm>
           <a:prstGeom prst="rect">
             <a:avLst/>
@@ -14026,8 +15703,10 @@
           <a:solidFill>
             <a:srgbClr val="FFFFFF"/>
           </a:solidFill>
-          <a:ln>
-            <a:noFill/>
+          <a:ln w="9525">
+            <a:solidFill>
+              <a:srgbClr val="D9D9D9"/>
+            </a:solidFill>
           </a:ln>
           <a:effectLst/>
         </p:spPr>
@@ -14061,8 +15740,8 @@
         </p:nvSpPr>
         <p:spPr>
           <a:xfrm>
-            <a:off x="9116567" y="384048"/>
-            <a:ext cx="2688336" cy="41148"/>
+            <a:off x="9098280" y="384048"/>
+            <a:ext cx="2706624" cy="41148"/>
           </a:xfrm>
           <a:prstGeom prst="rect">
             <a:avLst/>
@@ -14105,8 +15784,8 @@
         </p:nvSpPr>
         <p:spPr>
           <a:xfrm>
-            <a:off x="9281159" y="621792"/>
-            <a:ext cx="2359152" cy="3163824"/>
+            <a:off x="9244584" y="603503"/>
+            <a:ext cx="2414016" cy="3200400"/>
           </a:xfrm>
           <a:prstGeom prst="rect">
             <a:avLst/>
@@ -14121,7 +15800,7 @@
           <a:p>
             <a:pPr algn="l">
               <a:lnSpc>
-                <a:spcPct val="115000"/>
+                <a:spcPct val="112000"/>
               </a:lnSpc>
             </a:pPr>
             <a:r>
@@ -14137,14 +15816,14 @@
           <a:p>
             <a:pPr algn="l">
               <a:lnSpc>
-                <a:spcPct val="115000"/>
+                <a:spcPct val="112000"/>
               </a:lnSpc>
               <a:spcBef>
                 <a:spcPts val="200"/>
               </a:spcBef>
             </a:pPr>
             <a:r>
-              <a:rPr sz="1300" b="1">
+              <a:rPr sz="1200" b="1">
                 <a:solidFill>
                   <a:srgbClr val="3A3B68"/>
                 </a:solidFill>
@@ -14156,14 +15835,14 @@
           <a:p>
             <a:pPr algn="l">
               <a:lnSpc>
-                <a:spcPct val="115000"/>
+                <a:spcPct val="112000"/>
               </a:lnSpc>
               <a:spcBef>
                 <a:spcPts val="600"/>
               </a:spcBef>
             </a:pPr>
             <a:r>
-              <a:rPr sz="1100" b="0">
+              <a:rPr sz="1050" b="0">
                 <a:solidFill>
                   <a:srgbClr val="1E1E1E"/>
                 </a:solidFill>
@@ -14273,14 +15952,22 @@
         <p:spPr>
           <a:xfrm>
             <a:off x="3429000" y="384048"/>
-            <a:ext cx="4110228" cy="420624"/>
+            <a:ext cx="4123944" cy="292608"/>
           </a:xfrm>
           <a:prstGeom prst="rect">
             <a:avLst/>
           </a:prstGeom>
-          <a:solidFill>
-            <a:srgbClr val="3A3B68"/>
-          </a:solidFill>
+          <a:gradFill rotWithShape="1">
+            <a:gsLst>
+              <a:gs pos="0">
+                <a:srgbClr val="5D5E92"/>
+              </a:gs>
+              <a:gs pos="100000">
+                <a:srgbClr val="3A3B68"/>
+              </a:gs>
+            </a:gsLst>
+            <a:lin scaled="0" ang="18000000"/>
+          </a:gradFill>
           <a:ln>
             <a:noFill/>
           </a:ln>
@@ -14316,8 +16003,8 @@
         </p:nvSpPr>
         <p:spPr>
           <a:xfrm>
-            <a:off x="3557016" y="384048"/>
-            <a:ext cx="3854196" cy="420624"/>
+            <a:off x="3538728" y="384048"/>
+            <a:ext cx="3904487" cy="292608"/>
           </a:xfrm>
           <a:prstGeom prst="rect">
             <a:avLst/>
@@ -14330,13 +16017,13 @@
           </a:bodyPr>
           <a:lstStyle/>
           <a:p>
-            <a:pPr algn="l">
+            <a:pPr algn="ctr">
               <a:lnSpc>
-                <a:spcPct val="115000"/>
+                <a:spcPct val="112000"/>
               </a:lnSpc>
             </a:pPr>
             <a:r>
-              <a:rPr sz="1300" b="1">
+              <a:rPr sz="1200" b="1">
                 <a:solidFill>
                   <a:srgbClr val="FFFFFF"/>
                 </a:solidFill>
@@ -14355,8 +16042,8 @@
         </p:nvSpPr>
         <p:spPr>
           <a:xfrm>
-            <a:off x="3429000" y="804672"/>
-            <a:ext cx="4110228" cy="5294376"/>
+            <a:off x="3429000" y="713232"/>
+            <a:ext cx="4123944" cy="1443990"/>
           </a:xfrm>
           <a:prstGeom prst="rect">
             <a:avLst/>
@@ -14364,8 +16051,10 @@
           <a:solidFill>
             <a:srgbClr val="FFFFFF"/>
           </a:solidFill>
-          <a:ln>
-            <a:noFill/>
+          <a:ln w="9525">
+            <a:solidFill>
+              <a:srgbClr val="D9D9D9"/>
+            </a:solidFill>
           </a:ln>
           <a:effectLst/>
         </p:spPr>
@@ -14399,8 +16088,8 @@
         </p:nvSpPr>
         <p:spPr>
           <a:xfrm>
-            <a:off x="3557016" y="932688"/>
-            <a:ext cx="3854196" cy="5038344"/>
+            <a:off x="3538728" y="822960"/>
+            <a:ext cx="3904487" cy="1224534"/>
           </a:xfrm>
           <a:prstGeom prst="rect">
             <a:avLst/>
@@ -14415,14 +16104,14 @@
           <a:p>
             <a:pPr algn="l">
               <a:lnSpc>
-                <a:spcPct val="115000"/>
+                <a:spcPct val="112000"/>
               </a:lnSpc>
               <a:spcBef>
                 <a:spcPts val="400"/>
               </a:spcBef>
             </a:pPr>
             <a:r>
-              <a:rPr sz="1100" b="0">
+              <a:rPr sz="1050" b="0">
                 <a:solidFill>
                   <a:srgbClr val="1E1E1E"/>
                 </a:solidFill>
@@ -14434,14 +16123,14 @@
           <a:p>
             <a:pPr algn="l">
               <a:lnSpc>
-                <a:spcPct val="115000"/>
+                <a:spcPct val="112000"/>
               </a:lnSpc>
               <a:spcBef>
                 <a:spcPts val="400"/>
               </a:spcBef>
             </a:pPr>
             <a:r>
-              <a:rPr sz="1100" b="0">
+              <a:rPr sz="1050" b="0">
                 <a:solidFill>
                   <a:srgbClr val="1E1E1E"/>
                 </a:solidFill>
@@ -14453,14 +16142,14 @@
           <a:p>
             <a:pPr algn="l">
               <a:lnSpc>
-                <a:spcPct val="115000"/>
+                <a:spcPct val="112000"/>
               </a:lnSpc>
               <a:spcBef>
                 <a:spcPts val="400"/>
               </a:spcBef>
             </a:pPr>
             <a:r>
-              <a:rPr sz="1100" b="0">
+              <a:rPr sz="1050" b="0">
                 <a:solidFill>
                   <a:srgbClr val="1E1E1E"/>
                 </a:solidFill>
@@ -14472,14 +16161,14 @@
           <a:p>
             <a:pPr algn="l">
               <a:lnSpc>
-                <a:spcPct val="115000"/>
+                <a:spcPct val="112000"/>
               </a:lnSpc>
               <a:spcBef>
                 <a:spcPts val="400"/>
               </a:spcBef>
             </a:pPr>
             <a:r>
-              <a:rPr sz="1100" b="0">
+              <a:rPr sz="1050" b="0">
                 <a:solidFill>
                   <a:srgbClr val="1E1E1E"/>
                 </a:solidFill>
@@ -14498,15 +16187,23 @@
         </p:nvSpPr>
         <p:spPr>
           <a:xfrm>
-            <a:off x="7694675" y="384048"/>
-            <a:ext cx="4110228" cy="420624"/>
+            <a:off x="7680959" y="384048"/>
+            <a:ext cx="4123944" cy="292608"/>
           </a:xfrm>
           <a:prstGeom prst="rect">
             <a:avLst/>
           </a:prstGeom>
-          <a:solidFill>
-            <a:srgbClr val="C4996C"/>
-          </a:solidFill>
+          <a:gradFill rotWithShape="1">
+            <a:gsLst>
+              <a:gs pos="0">
+                <a:srgbClr val="C4996C"/>
+              </a:gs>
+              <a:gs pos="100000">
+                <a:srgbClr val="A87F4E"/>
+              </a:gs>
+            </a:gsLst>
+            <a:lin scaled="0" ang="18000000"/>
+          </a:gradFill>
           <a:ln>
             <a:noFill/>
           </a:ln>
@@ -14542,8 +16239,8 @@
         </p:nvSpPr>
         <p:spPr>
           <a:xfrm>
-            <a:off x="7822692" y="384048"/>
-            <a:ext cx="3854196" cy="420624"/>
+            <a:off x="7790687" y="384048"/>
+            <a:ext cx="3904487" cy="292608"/>
           </a:xfrm>
           <a:prstGeom prst="rect">
             <a:avLst/>
@@ -14556,13 +16253,13 @@
           </a:bodyPr>
           <a:lstStyle/>
           <a:p>
-            <a:pPr algn="l">
+            <a:pPr algn="ctr">
               <a:lnSpc>
-                <a:spcPct val="115000"/>
+                <a:spcPct val="112000"/>
               </a:lnSpc>
             </a:pPr>
             <a:r>
-              <a:rPr sz="1300" b="1">
+              <a:rPr sz="1200" b="1">
                 <a:solidFill>
                   <a:srgbClr val="FFFFFF"/>
                 </a:solidFill>
@@ -14581,8 +16278,8 @@
         </p:nvSpPr>
         <p:spPr>
           <a:xfrm>
-            <a:off x="7694675" y="804672"/>
-            <a:ext cx="4110228" cy="5294376"/>
+            <a:off x="7680959" y="713232"/>
+            <a:ext cx="4123944" cy="1443990"/>
           </a:xfrm>
           <a:prstGeom prst="rect">
             <a:avLst/>
@@ -14590,8 +16287,10 @@
           <a:solidFill>
             <a:srgbClr val="FFFFFF"/>
           </a:solidFill>
-          <a:ln>
-            <a:noFill/>
+          <a:ln w="9525">
+            <a:solidFill>
+              <a:srgbClr val="D9D9D9"/>
+            </a:solidFill>
           </a:ln>
           <a:effectLst/>
         </p:spPr>
@@ -14625,8 +16324,8 @@
         </p:nvSpPr>
         <p:spPr>
           <a:xfrm>
-            <a:off x="7822692" y="932688"/>
-            <a:ext cx="3854196" cy="5038344"/>
+            <a:off x="7790687" y="822960"/>
+            <a:ext cx="3904487" cy="1224534"/>
           </a:xfrm>
           <a:prstGeom prst="rect">
             <a:avLst/>
@@ -14641,14 +16340,14 @@
           <a:p>
             <a:pPr algn="l">
               <a:lnSpc>
-                <a:spcPct val="115000"/>
+                <a:spcPct val="112000"/>
               </a:lnSpc>
               <a:spcBef>
                 <a:spcPts val="400"/>
               </a:spcBef>
             </a:pPr>
             <a:r>
-              <a:rPr sz="1100" b="0">
+              <a:rPr sz="1050" b="0">
                 <a:solidFill>
                   <a:srgbClr val="1E1E1E"/>
                 </a:solidFill>
@@ -14660,14 +16359,14 @@
           <a:p>
             <a:pPr algn="l">
               <a:lnSpc>
-                <a:spcPct val="115000"/>
+                <a:spcPct val="112000"/>
               </a:lnSpc>
               <a:spcBef>
                 <a:spcPts val="400"/>
               </a:spcBef>
             </a:pPr>
             <a:r>
-              <a:rPr sz="1100" b="0">
+              <a:rPr sz="1050" b="0">
                 <a:solidFill>
                   <a:srgbClr val="1E1E1E"/>
                 </a:solidFill>
@@ -14679,14 +16378,14 @@
           <a:p>
             <a:pPr algn="l">
               <a:lnSpc>
-                <a:spcPct val="115000"/>
+                <a:spcPct val="112000"/>
               </a:lnSpc>
               <a:spcBef>
                 <a:spcPts val="400"/>
               </a:spcBef>
             </a:pPr>
             <a:r>
-              <a:rPr sz="1100" b="0">
+              <a:rPr sz="1050" b="0">
                 <a:solidFill>
                   <a:srgbClr val="1E1E1E"/>
                 </a:solidFill>
@@ -14698,14 +16397,14 @@
           <a:p>
             <a:pPr algn="l">
               <a:lnSpc>
-                <a:spcPct val="115000"/>
+                <a:spcPct val="112000"/>
               </a:lnSpc>
               <a:spcBef>
                 <a:spcPts val="400"/>
               </a:spcBef>
             </a:pPr>
             <a:r>
-              <a:rPr sz="1100" b="0">
+              <a:rPr sz="1050" b="0">
                 <a:solidFill>
                   <a:srgbClr val="1E1E1E"/>
                 </a:solidFill>
@@ -14815,14 +16514,22 @@
         <p:spPr>
           <a:xfrm>
             <a:off x="393192" y="1380744"/>
-            <a:ext cx="2738628" cy="502920"/>
+            <a:ext cx="2759202" cy="502920"/>
           </a:xfrm>
           <a:prstGeom prst="homePlate">
             <a:avLst/>
           </a:prstGeom>
-          <a:solidFill>
-            <a:srgbClr val="3A3B68"/>
-          </a:solidFill>
+          <a:gradFill rotWithShape="1">
+            <a:gsLst>
+              <a:gs pos="0">
+                <a:srgbClr val="5D5E92"/>
+              </a:gs>
+              <a:gs pos="100000">
+                <a:srgbClr val="3A3B68"/>
+              </a:gs>
+            </a:gsLst>
+            <a:lin scaled="0" ang="18000000"/>
+          </a:gradFill>
           <a:ln>
             <a:noFill/>
           </a:ln>
@@ -14859,7 +16566,7 @@
         <p:spPr>
           <a:xfrm>
             <a:off x="502920" y="1380744"/>
-            <a:ext cx="2519172" cy="502920"/>
+            <a:ext cx="2539746" cy="502920"/>
           </a:xfrm>
           <a:prstGeom prst="rect">
             <a:avLst/>
@@ -14874,11 +16581,11 @@
           <a:p>
             <a:pPr algn="ctr">
               <a:lnSpc>
-                <a:spcPct val="115000"/>
+                <a:spcPct val="112000"/>
               </a:lnSpc>
             </a:pPr>
             <a:r>
-              <a:rPr sz="1100" b="1">
+              <a:rPr sz="1050" b="1">
                 <a:solidFill>
                   <a:srgbClr val="FFFFFF"/>
                 </a:solidFill>
@@ -14898,7 +16605,7 @@
         <p:spPr>
           <a:xfrm>
             <a:off x="393192" y="1993392"/>
-            <a:ext cx="2738628" cy="4370832"/>
+            <a:ext cx="2759202" cy="4370832"/>
           </a:xfrm>
           <a:prstGeom prst="rect">
             <a:avLst/>
@@ -14913,14 +16620,14 @@
           <a:p>
             <a:pPr algn="l">
               <a:lnSpc>
-                <a:spcPct val="115000"/>
+                <a:spcPct val="112000"/>
               </a:lnSpc>
               <a:spcBef>
                 <a:spcPts val="400"/>
               </a:spcBef>
             </a:pPr>
             <a:r>
-              <a:rPr sz="1100" b="0">
+              <a:rPr sz="1050" b="0">
                 <a:solidFill>
                   <a:srgbClr val="1E1E1E"/>
                 </a:solidFill>
@@ -14939,15 +16646,23 @@
         </p:nvSpPr>
         <p:spPr>
           <a:xfrm>
-            <a:off x="3287268" y="1380744"/>
-            <a:ext cx="2738628" cy="502920"/>
+            <a:off x="3280410" y="1380744"/>
+            <a:ext cx="2759202" cy="502920"/>
           </a:xfrm>
           <a:prstGeom prst="chevron">
             <a:avLst/>
           </a:prstGeom>
-          <a:solidFill>
-            <a:srgbClr val="C4996C"/>
-          </a:solidFill>
+          <a:gradFill rotWithShape="1">
+            <a:gsLst>
+              <a:gs pos="0">
+                <a:srgbClr val="C4996C"/>
+              </a:gs>
+              <a:gs pos="100000">
+                <a:srgbClr val="A87F4E"/>
+              </a:gs>
+            </a:gsLst>
+            <a:lin scaled="0" ang="18000000"/>
+          </a:gradFill>
           <a:ln>
             <a:noFill/>
           </a:ln>
@@ -14983,8 +16698,8 @@
         </p:nvSpPr>
         <p:spPr>
           <a:xfrm>
-            <a:off x="3396996" y="1380744"/>
-            <a:ext cx="2519172" cy="502920"/>
+            <a:off x="3390138" y="1380744"/>
+            <a:ext cx="2539746" cy="502920"/>
           </a:xfrm>
           <a:prstGeom prst="rect">
             <a:avLst/>
@@ -14999,11 +16714,11 @@
           <a:p>
             <a:pPr algn="ctr">
               <a:lnSpc>
-                <a:spcPct val="115000"/>
+                <a:spcPct val="112000"/>
               </a:lnSpc>
             </a:pPr>
             <a:r>
-              <a:rPr sz="1100" b="1">
+              <a:rPr sz="1050" b="1">
                 <a:solidFill>
                   <a:srgbClr val="FFFFFF"/>
                 </a:solidFill>
@@ -15022,8 +16737,8 @@
         </p:nvSpPr>
         <p:spPr>
           <a:xfrm>
-            <a:off x="3287268" y="1993392"/>
-            <a:ext cx="2738628" cy="4370832"/>
+            <a:off x="3280410" y="1993392"/>
+            <a:ext cx="2759202" cy="4370832"/>
           </a:xfrm>
           <a:prstGeom prst="rect">
             <a:avLst/>
@@ -15038,14 +16753,14 @@
           <a:p>
             <a:pPr algn="l">
               <a:lnSpc>
-                <a:spcPct val="115000"/>
+                <a:spcPct val="112000"/>
               </a:lnSpc>
               <a:spcBef>
                 <a:spcPts val="400"/>
               </a:spcBef>
             </a:pPr>
             <a:r>
-              <a:rPr sz="1100" b="0">
+              <a:rPr sz="1050" b="0">
                 <a:solidFill>
                   <a:srgbClr val="1E1E1E"/>
                 </a:solidFill>
@@ -15064,15 +16779,23 @@
         </p:nvSpPr>
         <p:spPr>
           <a:xfrm>
-            <a:off x="6181344" y="1380744"/>
-            <a:ext cx="2738628" cy="502920"/>
+            <a:off x="6167628" y="1380744"/>
+            <a:ext cx="2759202" cy="502920"/>
           </a:xfrm>
           <a:prstGeom prst="chevron">
             <a:avLst/>
           </a:prstGeom>
-          <a:solidFill>
-            <a:srgbClr val="66689B"/>
-          </a:solidFill>
+          <a:gradFill rotWithShape="1">
+            <a:gsLst>
+              <a:gs pos="0">
+                <a:srgbClr val="66689B"/>
+              </a:gs>
+              <a:gs pos="100000">
+                <a:srgbClr val="505282"/>
+              </a:gs>
+            </a:gsLst>
+            <a:lin scaled="0" ang="18000000"/>
+          </a:gradFill>
           <a:ln>
             <a:noFill/>
           </a:ln>
@@ -15108,8 +16831,8 @@
         </p:nvSpPr>
         <p:spPr>
           <a:xfrm>
-            <a:off x="6291072" y="1380744"/>
-            <a:ext cx="2519172" cy="502920"/>
+            <a:off x="6277356" y="1380744"/>
+            <a:ext cx="2539746" cy="502920"/>
           </a:xfrm>
           <a:prstGeom prst="rect">
             <a:avLst/>
@@ -15124,11 +16847,11 @@
           <a:p>
             <a:pPr algn="ctr">
               <a:lnSpc>
-                <a:spcPct val="115000"/>
+                <a:spcPct val="112000"/>
               </a:lnSpc>
             </a:pPr>
             <a:r>
-              <a:rPr sz="1100" b="1">
+              <a:rPr sz="1050" b="1">
                 <a:solidFill>
                   <a:srgbClr val="FFFFFF"/>
                 </a:solidFill>
@@ -15147,8 +16870,8 @@
         </p:nvSpPr>
         <p:spPr>
           <a:xfrm>
-            <a:off x="6181344" y="1993392"/>
-            <a:ext cx="2738628" cy="4370832"/>
+            <a:off x="6167628" y="1993392"/>
+            <a:ext cx="2759202" cy="4370832"/>
           </a:xfrm>
           <a:prstGeom prst="rect">
             <a:avLst/>
@@ -15163,14 +16886,14 @@
           <a:p>
             <a:pPr algn="l">
               <a:lnSpc>
-                <a:spcPct val="115000"/>
+                <a:spcPct val="112000"/>
               </a:lnSpc>
               <a:spcBef>
                 <a:spcPts val="400"/>
               </a:spcBef>
             </a:pPr>
             <a:r>
-              <a:rPr sz="1100" b="0">
+              <a:rPr sz="1050" b="0">
                 <a:solidFill>
                   <a:srgbClr val="1E1E1E"/>
                 </a:solidFill>
@@ -15189,15 +16912,23 @@
         </p:nvSpPr>
         <p:spPr>
           <a:xfrm>
-            <a:off x="9075420" y="1380744"/>
-            <a:ext cx="2738628" cy="502920"/>
+            <a:off x="9054846" y="1380744"/>
+            <a:ext cx="2759202" cy="502920"/>
           </a:xfrm>
           <a:prstGeom prst="chevron">
             <a:avLst/>
           </a:prstGeom>
-          <a:solidFill>
-            <a:srgbClr val="C5A783"/>
-          </a:solidFill>
+          <a:gradFill rotWithShape="1">
+            <a:gsLst>
+              <a:gs pos="0">
+                <a:srgbClr val="5D5E92"/>
+              </a:gs>
+              <a:gs pos="100000">
+                <a:srgbClr val="3A3B68"/>
+              </a:gs>
+            </a:gsLst>
+            <a:lin scaled="0" ang="18000000"/>
+          </a:gradFill>
           <a:ln>
             <a:noFill/>
           </a:ln>
@@ -15233,8 +16964,8 @@
         </p:nvSpPr>
         <p:spPr>
           <a:xfrm>
-            <a:off x="9185148" y="1380744"/>
-            <a:ext cx="2519172" cy="502920"/>
+            <a:off x="9164574" y="1380744"/>
+            <a:ext cx="2539746" cy="502920"/>
           </a:xfrm>
           <a:prstGeom prst="rect">
             <a:avLst/>
@@ -15249,11 +16980,11 @@
           <a:p>
             <a:pPr algn="ctr">
               <a:lnSpc>
-                <a:spcPct val="115000"/>
+                <a:spcPct val="112000"/>
               </a:lnSpc>
             </a:pPr>
             <a:r>
-              <a:rPr sz="1100" b="1">
+              <a:rPr sz="1050" b="1">
                 <a:solidFill>
                   <a:srgbClr val="FFFFFF"/>
                 </a:solidFill>
@@ -15272,8 +17003,8 @@
         </p:nvSpPr>
         <p:spPr>
           <a:xfrm>
-            <a:off x="9075420" y="1993392"/>
-            <a:ext cx="2738628" cy="4370832"/>
+            <a:off x="9054846" y="1993392"/>
+            <a:ext cx="2759202" cy="4370832"/>
           </a:xfrm>
           <a:prstGeom prst="rect">
             <a:avLst/>
@@ -15288,14 +17019,14 @@
           <a:p>
             <a:pPr algn="l">
               <a:lnSpc>
-                <a:spcPct val="115000"/>
+                <a:spcPct val="112000"/>
               </a:lnSpc>
               <a:spcBef>
                 <a:spcPts val="400"/>
               </a:spcBef>
             </a:pPr>
             <a:r>
-              <a:rPr sz="1100" b="0">
+              <a:rPr sz="1050" b="0">
                 <a:solidFill>
                   <a:srgbClr val="1E1E1E"/>
                 </a:solidFill>
@@ -15486,14 +17217,60 @@
       </p:sp>
       <p:sp>
         <p:nvSpPr>
-          <p:cNvPr id="8" name="TextBox 7"/>
+          <p:cNvPr id="8" name="Rounded Rectangle 7"/>
+          <p:cNvSpPr/>
+          <p:nvPr/>
+        </p:nvSpPr>
+        <p:spPr>
+          <a:xfrm>
+            <a:off x="1094536" y="2998317"/>
+            <a:ext cx="822960" cy="237744"/>
+          </a:xfrm>
+          <a:prstGeom prst="roundRect">
+            <a:avLst>
+              <a:gd name="adj" fmla="val 50000"/>
+            </a:avLst>
+          </a:prstGeom>
+          <a:solidFill>
+            <a:srgbClr val="3A3B68"/>
+          </a:solidFill>
+          <a:ln>
+            <a:noFill/>
+          </a:ln>
+          <a:effectLst/>
+        </p:spPr>
+        <p:style>
+          <a:lnRef idx="1">
+            <a:schemeClr val="accent1"/>
+          </a:lnRef>
+          <a:fillRef idx="3">
+            <a:schemeClr val="accent1"/>
+          </a:fillRef>
+          <a:effectRef idx="2">
+            <a:schemeClr val="accent1"/>
+          </a:effectRef>
+          <a:fontRef idx="minor">
+            <a:schemeClr val="lt1"/>
+          </a:fontRef>
+        </p:style>
+        <p:txBody>
+          <a:bodyPr rtlCol="0" anchor="ctr" wrap="square"/>
+          <a:lstStyle/>
+          <a:p>
+            <a:pPr algn="ctr"/>
+          </a:p>
+        </p:txBody>
+      </p:sp>
+      <p:sp>
+        <p:nvSpPr>
+          <p:cNvPr id="9" name="TextBox 8"/>
           <p:cNvSpPr txBox="1"/>
           <p:nvPr/>
         </p:nvSpPr>
         <p:spPr>
           <a:xfrm>
-            <a:off x="393192" y="2906877"/>
-            <a:ext cx="2225649" cy="457200"/>
+            <a:off x="1094536" y="2998317"/>
+            <a:ext cx="822960" cy="237744"/>
           </a:xfrm>
           <a:prstGeom prst="rect">
             <a:avLst/>
@@ -15501,20 +17278,20 @@
           <a:noFill/>
         </p:spPr>
         <p:txBody>
-          <a:bodyPr wrap="square" anchor="b" lIns="0" rIns="0" tIns="0" bIns="0">
+          <a:bodyPr wrap="square" anchor="ctr" lIns="0" rIns="0" tIns="0" bIns="0">
             <a:spAutoFit/>
           </a:bodyPr>
           <a:lstStyle/>
           <a:p>
             <a:pPr algn="ctr">
               <a:lnSpc>
-                <a:spcPct val="115000"/>
+                <a:spcPct val="112000"/>
               </a:lnSpc>
             </a:pPr>
             <a:r>
-              <a:rPr sz="950" b="1">
+              <a:rPr sz="900" b="1">
                 <a:solidFill>
-                  <a:srgbClr val="C4996C"/>
+                  <a:srgbClr val="FFFFFF"/>
                 </a:solidFill>
                 <a:latin typeface="Arial"/>
               </a:rPr>
@@ -15525,7 +17302,7 @@
       </p:sp>
       <p:sp>
         <p:nvSpPr>
-          <p:cNvPr id="9" name="TextBox 8"/>
+          <p:cNvPr id="10" name="TextBox 9"/>
           <p:cNvSpPr txBox="1"/>
           <p:nvPr/>
         </p:nvSpPr>
@@ -15547,11 +17324,11 @@
           <a:p>
             <a:pPr algn="ctr">
               <a:lnSpc>
-                <a:spcPct val="115000"/>
+                <a:spcPct val="112000"/>
               </a:lnSpc>
             </a:pPr>
             <a:r>
-              <a:rPr sz="1100" b="0">
+              <a:rPr sz="1050" b="0">
                 <a:solidFill>
                   <a:srgbClr val="1E1E1E"/>
                 </a:solidFill>
@@ -15564,7 +17341,7 @@
       </p:sp>
       <p:sp>
         <p:nvSpPr>
-          <p:cNvPr id="10" name="Oval 9"/>
+          <p:cNvPr id="11" name="Oval 10"/>
           <p:cNvSpPr/>
           <p:nvPr/>
         </p:nvSpPr>
@@ -15610,14 +17387,60 @@
       </p:sp>
       <p:sp>
         <p:nvSpPr>
-          <p:cNvPr id="11" name="TextBox 10"/>
+          <p:cNvPr id="12" name="Rounded Rectangle 11"/>
+          <p:cNvSpPr/>
+          <p:nvPr/>
+        </p:nvSpPr>
+        <p:spPr>
+          <a:xfrm>
+            <a:off x="3393338" y="2998317"/>
+            <a:ext cx="822960" cy="237744"/>
+          </a:xfrm>
+          <a:prstGeom prst="roundRect">
+            <a:avLst>
+              <a:gd name="adj" fmla="val 50000"/>
+            </a:avLst>
+          </a:prstGeom>
+          <a:solidFill>
+            <a:srgbClr val="66689B"/>
+          </a:solidFill>
+          <a:ln>
+            <a:noFill/>
+          </a:ln>
+          <a:effectLst/>
+        </p:spPr>
+        <p:style>
+          <a:lnRef idx="1">
+            <a:schemeClr val="accent1"/>
+          </a:lnRef>
+          <a:fillRef idx="3">
+            <a:schemeClr val="accent1"/>
+          </a:fillRef>
+          <a:effectRef idx="2">
+            <a:schemeClr val="accent1"/>
+          </a:effectRef>
+          <a:fontRef idx="minor">
+            <a:schemeClr val="lt1"/>
+          </a:fontRef>
+        </p:style>
+        <p:txBody>
+          <a:bodyPr rtlCol="0" anchor="ctr" wrap="square"/>
+          <a:lstStyle/>
+          <a:p>
+            <a:pPr algn="ctr"/>
+          </a:p>
+        </p:txBody>
+      </p:sp>
+      <p:sp>
+        <p:nvSpPr>
+          <p:cNvPr id="13" name="TextBox 12"/>
           <p:cNvSpPr txBox="1"/>
           <p:nvPr/>
         </p:nvSpPr>
         <p:spPr>
           <a:xfrm>
-            <a:off x="2691993" y="2906877"/>
-            <a:ext cx="2225649" cy="457200"/>
+            <a:off x="3393338" y="2998317"/>
+            <a:ext cx="822960" cy="237744"/>
           </a:xfrm>
           <a:prstGeom prst="rect">
             <a:avLst/>
@@ -15625,20 +17448,20 @@
           <a:noFill/>
         </p:spPr>
         <p:txBody>
-          <a:bodyPr wrap="square" anchor="b" lIns="0" rIns="0" tIns="0" bIns="0">
+          <a:bodyPr wrap="square" anchor="ctr" lIns="0" rIns="0" tIns="0" bIns="0">
             <a:spAutoFit/>
           </a:bodyPr>
           <a:lstStyle/>
           <a:p>
             <a:pPr algn="ctr">
               <a:lnSpc>
-                <a:spcPct val="115000"/>
+                <a:spcPct val="112000"/>
               </a:lnSpc>
             </a:pPr>
             <a:r>
-              <a:rPr sz="950" b="1">
+              <a:rPr sz="900" b="1">
                 <a:solidFill>
-                  <a:srgbClr val="C4996C"/>
+                  <a:srgbClr val="FFFFFF"/>
                 </a:solidFill>
                 <a:latin typeface="Arial"/>
               </a:rPr>
@@ -15649,7 +17472,7 @@
       </p:sp>
       <p:sp>
         <p:nvSpPr>
-          <p:cNvPr id="12" name="TextBox 11"/>
+          <p:cNvPr id="14" name="TextBox 13"/>
           <p:cNvSpPr txBox="1"/>
           <p:nvPr/>
         </p:nvSpPr>
@@ -15671,11 +17494,11 @@
           <a:p>
             <a:pPr algn="ctr">
               <a:lnSpc>
-                <a:spcPct val="115000"/>
+                <a:spcPct val="112000"/>
               </a:lnSpc>
             </a:pPr>
             <a:r>
-              <a:rPr sz="1100" b="0">
+              <a:rPr sz="1050" b="0">
                 <a:solidFill>
                   <a:srgbClr val="1E1E1E"/>
                 </a:solidFill>
@@ -15688,7 +17511,7 @@
       </p:sp>
       <p:sp>
         <p:nvSpPr>
-          <p:cNvPr id="13" name="Oval 12"/>
+          <p:cNvPr id="15" name="Oval 14"/>
           <p:cNvSpPr/>
           <p:nvPr/>
         </p:nvSpPr>
@@ -15734,14 +17557,60 @@
       </p:sp>
       <p:sp>
         <p:nvSpPr>
-          <p:cNvPr id="14" name="TextBox 13"/>
+          <p:cNvPr id="16" name="Rounded Rectangle 15"/>
+          <p:cNvSpPr/>
+          <p:nvPr/>
+        </p:nvSpPr>
+        <p:spPr>
+          <a:xfrm>
+            <a:off x="5692140" y="2998317"/>
+            <a:ext cx="822960" cy="237744"/>
+          </a:xfrm>
+          <a:prstGeom prst="roundRect">
+            <a:avLst>
+              <a:gd name="adj" fmla="val 50000"/>
+            </a:avLst>
+          </a:prstGeom>
+          <a:solidFill>
+            <a:srgbClr val="66689B"/>
+          </a:solidFill>
+          <a:ln>
+            <a:noFill/>
+          </a:ln>
+          <a:effectLst/>
+        </p:spPr>
+        <p:style>
+          <a:lnRef idx="1">
+            <a:schemeClr val="accent1"/>
+          </a:lnRef>
+          <a:fillRef idx="3">
+            <a:schemeClr val="accent1"/>
+          </a:fillRef>
+          <a:effectRef idx="2">
+            <a:schemeClr val="accent1"/>
+          </a:effectRef>
+          <a:fontRef idx="minor">
+            <a:schemeClr val="lt1"/>
+          </a:fontRef>
+        </p:style>
+        <p:txBody>
+          <a:bodyPr rtlCol="0" anchor="ctr" wrap="square"/>
+          <a:lstStyle/>
+          <a:p>
+            <a:pPr algn="ctr"/>
+          </a:p>
+        </p:txBody>
+      </p:sp>
+      <p:sp>
+        <p:nvSpPr>
+          <p:cNvPr id="17" name="TextBox 16"/>
           <p:cNvSpPr txBox="1"/>
           <p:nvPr/>
         </p:nvSpPr>
         <p:spPr>
           <a:xfrm>
-            <a:off x="4990795" y="2906877"/>
-            <a:ext cx="2225649" cy="457200"/>
+            <a:off x="5692140" y="2998317"/>
+            <a:ext cx="822960" cy="237744"/>
           </a:xfrm>
           <a:prstGeom prst="rect">
             <a:avLst/>
@@ -15749,20 +17618,20 @@
           <a:noFill/>
         </p:spPr>
         <p:txBody>
-          <a:bodyPr wrap="square" anchor="b" lIns="0" rIns="0" tIns="0" bIns="0">
+          <a:bodyPr wrap="square" anchor="ctr" lIns="0" rIns="0" tIns="0" bIns="0">
             <a:spAutoFit/>
           </a:bodyPr>
           <a:lstStyle/>
           <a:p>
             <a:pPr algn="ctr">
               <a:lnSpc>
-                <a:spcPct val="115000"/>
+                <a:spcPct val="112000"/>
               </a:lnSpc>
             </a:pPr>
             <a:r>
-              <a:rPr sz="950" b="1">
+              <a:rPr sz="900" b="1">
                 <a:solidFill>
-                  <a:srgbClr val="C4996C"/>
+                  <a:srgbClr val="FFFFFF"/>
                 </a:solidFill>
                 <a:latin typeface="Arial"/>
               </a:rPr>
@@ -15773,7 +17642,7 @@
       </p:sp>
       <p:sp>
         <p:nvSpPr>
-          <p:cNvPr id="15" name="TextBox 14"/>
+          <p:cNvPr id="18" name="TextBox 17"/>
           <p:cNvSpPr txBox="1"/>
           <p:nvPr/>
         </p:nvSpPr>
@@ -15795,11 +17664,11 @@
           <a:p>
             <a:pPr algn="ctr">
               <a:lnSpc>
-                <a:spcPct val="115000"/>
+                <a:spcPct val="112000"/>
               </a:lnSpc>
             </a:pPr>
             <a:r>
-              <a:rPr sz="1100" b="0">
+              <a:rPr sz="1050" b="0">
                 <a:solidFill>
                   <a:srgbClr val="1E1E1E"/>
                 </a:solidFill>
@@ -15812,7 +17681,7 @@
       </p:sp>
       <p:sp>
         <p:nvSpPr>
-          <p:cNvPr id="16" name="Oval 15"/>
+          <p:cNvPr id="19" name="Oval 18"/>
           <p:cNvSpPr/>
           <p:nvPr/>
         </p:nvSpPr>
@@ -15858,14 +17727,60 @@
       </p:sp>
       <p:sp>
         <p:nvSpPr>
-          <p:cNvPr id="17" name="TextBox 16"/>
+          <p:cNvPr id="20" name="Rounded Rectangle 19"/>
+          <p:cNvSpPr/>
+          <p:nvPr/>
+        </p:nvSpPr>
+        <p:spPr>
+          <a:xfrm>
+            <a:off x="7990941" y="2998317"/>
+            <a:ext cx="822960" cy="237744"/>
+          </a:xfrm>
+          <a:prstGeom prst="roundRect">
+            <a:avLst>
+              <a:gd name="adj" fmla="val 50000"/>
+            </a:avLst>
+          </a:prstGeom>
+          <a:solidFill>
+            <a:srgbClr val="66689B"/>
+          </a:solidFill>
+          <a:ln>
+            <a:noFill/>
+          </a:ln>
+          <a:effectLst/>
+        </p:spPr>
+        <p:style>
+          <a:lnRef idx="1">
+            <a:schemeClr val="accent1"/>
+          </a:lnRef>
+          <a:fillRef idx="3">
+            <a:schemeClr val="accent1"/>
+          </a:fillRef>
+          <a:effectRef idx="2">
+            <a:schemeClr val="accent1"/>
+          </a:effectRef>
+          <a:fontRef idx="minor">
+            <a:schemeClr val="lt1"/>
+          </a:fontRef>
+        </p:style>
+        <p:txBody>
+          <a:bodyPr rtlCol="0" anchor="ctr" wrap="square"/>
+          <a:lstStyle/>
+          <a:p>
+            <a:pPr algn="ctr"/>
+          </a:p>
+        </p:txBody>
+      </p:sp>
+      <p:sp>
+        <p:nvSpPr>
+          <p:cNvPr id="21" name="TextBox 20"/>
           <p:cNvSpPr txBox="1"/>
           <p:nvPr/>
         </p:nvSpPr>
         <p:spPr>
           <a:xfrm>
-            <a:off x="7289596" y="2906877"/>
-            <a:ext cx="2225649" cy="457200"/>
+            <a:off x="7990941" y="2998317"/>
+            <a:ext cx="822960" cy="237744"/>
           </a:xfrm>
           <a:prstGeom prst="rect">
             <a:avLst/>
@@ -15873,20 +17788,20 @@
           <a:noFill/>
         </p:spPr>
         <p:txBody>
-          <a:bodyPr wrap="square" anchor="b" lIns="0" rIns="0" tIns="0" bIns="0">
+          <a:bodyPr wrap="square" anchor="ctr" lIns="0" rIns="0" tIns="0" bIns="0">
             <a:spAutoFit/>
           </a:bodyPr>
           <a:lstStyle/>
           <a:p>
             <a:pPr algn="ctr">
               <a:lnSpc>
-                <a:spcPct val="115000"/>
+                <a:spcPct val="112000"/>
               </a:lnSpc>
             </a:pPr>
             <a:r>
-              <a:rPr sz="950" b="1">
+              <a:rPr sz="900" b="1">
                 <a:solidFill>
-                  <a:srgbClr val="C4996C"/>
+                  <a:srgbClr val="FFFFFF"/>
                 </a:solidFill>
                 <a:latin typeface="Arial"/>
               </a:rPr>
@@ -15897,7 +17812,7 @@
       </p:sp>
       <p:sp>
         <p:nvSpPr>
-          <p:cNvPr id="18" name="TextBox 17"/>
+          <p:cNvPr id="22" name="TextBox 21"/>
           <p:cNvSpPr txBox="1"/>
           <p:nvPr/>
         </p:nvSpPr>
@@ -15919,11 +17834,11 @@
           <a:p>
             <a:pPr algn="ctr">
               <a:lnSpc>
-                <a:spcPct val="115000"/>
+                <a:spcPct val="112000"/>
               </a:lnSpc>
             </a:pPr>
             <a:r>
-              <a:rPr sz="1100" b="0">
+              <a:rPr sz="1050" b="0">
                 <a:solidFill>
                   <a:srgbClr val="1E1E1E"/>
                 </a:solidFill>
@@ -15936,7 +17851,7 @@
       </p:sp>
       <p:sp>
         <p:nvSpPr>
-          <p:cNvPr id="19" name="Oval 18"/>
+          <p:cNvPr id="23" name="Oval 22"/>
           <p:cNvSpPr/>
           <p:nvPr/>
         </p:nvSpPr>
@@ -15982,14 +17897,60 @@
       </p:sp>
       <p:sp>
         <p:nvSpPr>
-          <p:cNvPr id="20" name="TextBox 19"/>
+          <p:cNvPr id="24" name="Rounded Rectangle 23"/>
+          <p:cNvSpPr/>
+          <p:nvPr/>
+        </p:nvSpPr>
+        <p:spPr>
+          <a:xfrm>
+            <a:off x="10289743" y="2998317"/>
+            <a:ext cx="822960" cy="237744"/>
+          </a:xfrm>
+          <a:prstGeom prst="roundRect">
+            <a:avLst>
+              <a:gd name="adj" fmla="val 50000"/>
+            </a:avLst>
+          </a:prstGeom>
+          <a:solidFill>
+            <a:srgbClr val="66689B"/>
+          </a:solidFill>
+          <a:ln>
+            <a:noFill/>
+          </a:ln>
+          <a:effectLst/>
+        </p:spPr>
+        <p:style>
+          <a:lnRef idx="1">
+            <a:schemeClr val="accent1"/>
+          </a:lnRef>
+          <a:fillRef idx="3">
+            <a:schemeClr val="accent1"/>
+          </a:fillRef>
+          <a:effectRef idx="2">
+            <a:schemeClr val="accent1"/>
+          </a:effectRef>
+          <a:fontRef idx="minor">
+            <a:schemeClr val="lt1"/>
+          </a:fontRef>
+        </p:style>
+        <p:txBody>
+          <a:bodyPr rtlCol="0" anchor="ctr" wrap="square"/>
+          <a:lstStyle/>
+          <a:p>
+            <a:pPr algn="ctr"/>
+          </a:p>
+        </p:txBody>
+      </p:sp>
+      <p:sp>
+        <p:nvSpPr>
+          <p:cNvPr id="25" name="TextBox 24"/>
           <p:cNvSpPr txBox="1"/>
           <p:nvPr/>
         </p:nvSpPr>
         <p:spPr>
           <a:xfrm>
-            <a:off x="9588398" y="2906877"/>
-            <a:ext cx="2225649" cy="457200"/>
+            <a:off x="10289743" y="2998317"/>
+            <a:ext cx="822960" cy="237744"/>
           </a:xfrm>
           <a:prstGeom prst="rect">
             <a:avLst/>
@@ -15997,20 +17958,20 @@
           <a:noFill/>
         </p:spPr>
         <p:txBody>
-          <a:bodyPr wrap="square" anchor="b" lIns="0" rIns="0" tIns="0" bIns="0">
+          <a:bodyPr wrap="square" anchor="ctr" lIns="0" rIns="0" tIns="0" bIns="0">
             <a:spAutoFit/>
           </a:bodyPr>
           <a:lstStyle/>
           <a:p>
             <a:pPr algn="ctr">
               <a:lnSpc>
-                <a:spcPct val="115000"/>
+                <a:spcPct val="112000"/>
               </a:lnSpc>
             </a:pPr>
             <a:r>
-              <a:rPr sz="950" b="1">
+              <a:rPr sz="900" b="1">
                 <a:solidFill>
-                  <a:srgbClr val="C4996C"/>
+                  <a:srgbClr val="FFFFFF"/>
                 </a:solidFill>
                 <a:latin typeface="Arial"/>
               </a:rPr>
@@ -16021,7 +17982,7 @@
       </p:sp>
       <p:sp>
         <p:nvSpPr>
-          <p:cNvPr id="21" name="TextBox 20"/>
+          <p:cNvPr id="26" name="TextBox 25"/>
           <p:cNvSpPr txBox="1"/>
           <p:nvPr/>
         </p:nvSpPr>
@@ -16043,11 +18004,11 @@
           <a:p>
             <a:pPr algn="ctr">
               <a:lnSpc>
-                <a:spcPct val="115000"/>
+                <a:spcPct val="112000"/>
               </a:lnSpc>
             </a:pPr>
             <a:r>
-              <a:rPr sz="1100" b="0">
+              <a:rPr sz="1050" b="0">
                 <a:solidFill>
                   <a:srgbClr val="1E1E1E"/>
                 </a:solidFill>
@@ -16156,8 +18117,99 @@
         </p:nvSpPr>
         <p:spPr>
           <a:xfrm>
-            <a:off x="9009948" y="384048"/>
-            <a:ext cx="2794955" cy="5715000"/>
+            <a:off x="9000622" y="384048"/>
+            <a:ext cx="2804281" cy="292608"/>
+          </a:xfrm>
+          <a:prstGeom prst="rect">
+            <a:avLst/>
+          </a:prstGeom>
+          <a:gradFill rotWithShape="1">
+            <a:gsLst>
+              <a:gs pos="0">
+                <a:srgbClr val="5D5E92"/>
+              </a:gs>
+              <a:gs pos="100000">
+                <a:srgbClr val="3A3B68"/>
+              </a:gs>
+            </a:gsLst>
+            <a:lin scaled="0" ang="18000000"/>
+          </a:gradFill>
+          <a:ln>
+            <a:noFill/>
+          </a:ln>
+          <a:effectLst/>
+        </p:spPr>
+        <p:style>
+          <a:lnRef idx="1">
+            <a:schemeClr val="accent1"/>
+          </a:lnRef>
+          <a:fillRef idx="3">
+            <a:schemeClr val="accent1"/>
+          </a:fillRef>
+          <a:effectRef idx="2">
+            <a:schemeClr val="accent1"/>
+          </a:effectRef>
+          <a:fontRef idx="minor">
+            <a:schemeClr val="lt1"/>
+          </a:fontRef>
+        </p:style>
+        <p:txBody>
+          <a:bodyPr rtlCol="0" anchor="ctr" wrap="square"/>
+          <a:lstStyle/>
+          <a:p>
+            <a:pPr algn="ctr"/>
+          </a:p>
+        </p:txBody>
+      </p:sp>
+      <p:sp>
+        <p:nvSpPr>
+          <p:cNvPr id="6" name="TextBox 5"/>
+          <p:cNvSpPr txBox="1"/>
+          <p:nvPr/>
+        </p:nvSpPr>
+        <p:spPr>
+          <a:xfrm>
+            <a:off x="9110350" y="384048"/>
+            <a:ext cx="2584825" cy="292608"/>
+          </a:xfrm>
+          <a:prstGeom prst="rect">
+            <a:avLst/>
+          </a:prstGeom>
+          <a:noFill/>
+        </p:spPr>
+        <p:txBody>
+          <a:bodyPr wrap="square" anchor="ctr" lIns="0" rIns="0" tIns="0" bIns="0">
+            <a:spAutoFit/>
+          </a:bodyPr>
+          <a:lstStyle/>
+          <a:p>
+            <a:pPr algn="ctr">
+              <a:lnSpc>
+                <a:spcPct val="112000"/>
+              </a:lnSpc>
+            </a:pPr>
+            <a:r>
+              <a:rPr sz="1200" b="1">
+                <a:solidFill>
+                  <a:srgbClr val="FFFFFF"/>
+                </a:solidFill>
+                <a:latin typeface="Arial"/>
+              </a:rPr>
+              <a:t>Key takeaways</a:t>
+            </a:r>
+          </a:p>
+        </p:txBody>
+      </p:sp>
+      <p:sp>
+        <p:nvSpPr>
+          <p:cNvPr id="7" name="Rectangle 6"/>
+          <p:cNvSpPr/>
+          <p:nvPr/>
+        </p:nvSpPr>
+        <p:spPr>
+          <a:xfrm>
+            <a:off x="9000622" y="713232"/>
+            <a:ext cx="2804281" cy="5385816"/>
           </a:xfrm>
           <a:prstGeom prst="rect">
             <a:avLst/>
@@ -16165,8 +18217,10 @@
           <a:solidFill>
             <a:srgbClr val="FFFFFF"/>
           </a:solidFill>
-          <a:ln>
-            <a:noFill/>
+          <a:ln w="9525">
+            <a:solidFill>
+              <a:srgbClr val="D9D9D9"/>
+            </a:solidFill>
           </a:ln>
           <a:effectLst/>
         </p:spPr>
@@ -16194,58 +18248,14 @@
       </p:sp>
       <p:sp>
         <p:nvSpPr>
-          <p:cNvPr id="6" name="Rectangle 5"/>
-          <p:cNvSpPr/>
-          <p:nvPr/>
-        </p:nvSpPr>
-        <p:spPr>
-          <a:xfrm>
-            <a:off x="9009948" y="384048"/>
-            <a:ext cx="2794955" cy="41148"/>
-          </a:xfrm>
-          <a:prstGeom prst="rect">
-            <a:avLst/>
-          </a:prstGeom>
-          <a:solidFill>
-            <a:srgbClr val="3A3B68"/>
-          </a:solidFill>
-          <a:ln>
-            <a:noFill/>
-          </a:ln>
-          <a:effectLst/>
-        </p:spPr>
-        <p:style>
-          <a:lnRef idx="1">
-            <a:schemeClr val="accent1"/>
-          </a:lnRef>
-          <a:fillRef idx="3">
-            <a:schemeClr val="accent1"/>
-          </a:fillRef>
-          <a:effectRef idx="2">
-            <a:schemeClr val="accent1"/>
-          </a:effectRef>
-          <a:fontRef idx="minor">
-            <a:schemeClr val="lt1"/>
-          </a:fontRef>
-        </p:style>
-        <p:txBody>
-          <a:bodyPr rtlCol="0" anchor="ctr" wrap="square"/>
-          <a:lstStyle/>
-          <a:p>
-            <a:pPr algn="ctr"/>
-          </a:p>
-        </p:txBody>
-      </p:sp>
-      <p:sp>
-        <p:nvSpPr>
-          <p:cNvPr id="7" name="TextBox 6"/>
+          <p:cNvPr id="8" name="TextBox 7"/>
           <p:cNvSpPr txBox="1"/>
           <p:nvPr/>
         </p:nvSpPr>
         <p:spPr>
           <a:xfrm>
-            <a:off x="9137964" y="603504"/>
-            <a:ext cx="2538923" cy="5367528"/>
+            <a:off x="9110350" y="822960"/>
+            <a:ext cx="2584825" cy="5166359"/>
           </a:xfrm>
           <a:prstGeom prst="rect">
             <a:avLst/>
@@ -16260,30 +18270,14 @@
           <a:p>
             <a:pPr algn="l">
               <a:lnSpc>
-                <a:spcPct val="115000"/>
-              </a:lnSpc>
-            </a:pPr>
-            <a:r>
-              <a:rPr sz="1300" b="1">
-                <a:solidFill>
-                  <a:srgbClr val="3A3B68"/>
-                </a:solidFill>
-                <a:latin typeface="Arial"/>
-              </a:rPr>
-              <a:t>Key takeaways</a:t>
-            </a:r>
-          </a:p>
-          <a:p>
-            <a:pPr algn="l">
-              <a:lnSpc>
-                <a:spcPct val="115000"/>
+                <a:spcPct val="112000"/>
               </a:lnSpc>
               <a:spcBef>
                 <a:spcPts val="400"/>
               </a:spcBef>
             </a:pPr>
             <a:r>
-              <a:rPr sz="1100" b="0">
+              <a:rPr sz="1050" b="0">
                 <a:solidFill>
                   <a:srgbClr val="1E1E1E"/>
                 </a:solidFill>
@@ -16295,14 +18289,14 @@
           <a:p>
             <a:pPr algn="l">
               <a:lnSpc>
-                <a:spcPct val="115000"/>
+                <a:spcPct val="112000"/>
               </a:lnSpc>
               <a:spcBef>
                 <a:spcPts val="400"/>
               </a:spcBef>
             </a:pPr>
             <a:r>
-              <a:rPr sz="1100" b="0">
+              <a:rPr sz="1050" b="0">
                 <a:solidFill>
                   <a:srgbClr val="1E1E1E"/>
                 </a:solidFill>
@@ -16314,14 +18308,14 @@
           <a:p>
             <a:pPr algn="l">
               <a:lnSpc>
-                <a:spcPct val="115000"/>
+                <a:spcPct val="112000"/>
               </a:lnSpc>
               <a:spcBef>
                 <a:spcPts val="400"/>
               </a:spcBef>
             </a:pPr>
             <a:r>
-              <a:rPr sz="1100" b="0">
+              <a:rPr sz="1050" b="0">
                 <a:solidFill>
                   <a:srgbClr val="1E1E1E"/>
                 </a:solidFill>
@@ -16334,14 +18328,14 @@
       </p:sp>
       <p:sp>
         <p:nvSpPr>
-          <p:cNvPr id="8" name="Rectangle 7"/>
+          <p:cNvPr id="9" name="Rectangle 8"/>
           <p:cNvSpPr/>
           <p:nvPr/>
         </p:nvSpPr>
         <p:spPr>
           <a:xfrm>
             <a:off x="3429000" y="384048"/>
-            <a:ext cx="5425500" cy="5715000"/>
+            <a:ext cx="5443606" cy="5715000"/>
           </a:xfrm>
           <a:prstGeom prst="rect">
             <a:avLst/>
@@ -16349,8 +18343,10 @@
           <a:solidFill>
             <a:srgbClr val="FFFFFF"/>
           </a:solidFill>
-          <a:ln>
-            <a:noFill/>
+          <a:ln w="9525">
+            <a:solidFill>
+              <a:srgbClr val="D9D9D9"/>
+            </a:solidFill>
           </a:ln>
           <a:effectLst/>
         </p:spPr>
@@ -16378,7 +18374,7 @@
       </p:sp>
       <p:graphicFrame>
         <p:nvGraphicFramePr>
-          <p:cNvPr id="9" name="Chart 8"/>
+          <p:cNvPr id="10" name="Chart 9"/>
           <p:cNvGraphicFramePr>
             <a:graphicFrameLocks noGrp="1"/>
           </p:cNvGraphicFramePr>
@@ -16386,7 +18382,7 @@
         </p:nvGraphicFramePr>
         <p:xfrm>
           <a:off x="3593592" y="530352"/>
-          <a:ext cx="5096316" cy="5422392"/>
+          <a:ext cx="5114422" cy="5422392"/>
         </p:xfrm>
         <a:graphic>
           <a:graphicData uri="http://schemas.openxmlformats.org/drawingml/2006/chart">
@@ -16517,7 +18513,7 @@
                     <a:p>
                       <a:pPr algn="l"/>
                       <a:r>
-                        <a:rPr sz="1100" b="1">
+                        <a:rPr sz="1050" b="1">
                           <a:solidFill>
                             <a:srgbClr val="FFFFFF"/>
                           </a:solidFill>
@@ -16540,7 +18536,7 @@
                     <a:p>
                       <a:pPr algn="l"/>
                       <a:r>
-                        <a:rPr sz="1100" b="1">
+                        <a:rPr sz="1050" b="1">
                           <a:solidFill>
                             <a:srgbClr val="FFFFFF"/>
                           </a:solidFill>
@@ -16563,7 +18559,7 @@
                     <a:p>
                       <a:pPr algn="l"/>
                       <a:r>
-                        <a:rPr sz="1100" b="1">
+                        <a:rPr sz="1050" b="1">
                           <a:solidFill>
                             <a:srgbClr val="FFFFFF"/>
                           </a:solidFill>
@@ -16586,7 +18582,7 @@
                     <a:p>
                       <a:pPr algn="l"/>
                       <a:r>
-                        <a:rPr sz="1100" b="1">
+                        <a:rPr sz="1050" b="1">
                           <a:solidFill>
                             <a:srgbClr val="FFFFFF"/>
                           </a:solidFill>
@@ -16609,7 +18605,7 @@
                     <a:p>
                       <a:pPr algn="l"/>
                       <a:r>
-                        <a:rPr sz="1100" b="1">
+                        <a:rPr sz="1050" b="1">
                           <a:solidFill>
                             <a:srgbClr val="FFFFFF"/>
                           </a:solidFill>
@@ -16634,7 +18630,7 @@
                     <a:p>
                       <a:pPr algn="l"/>
                       <a:r>
-                        <a:rPr sz="1100" b="0">
+                        <a:rPr sz="1050" b="0">
                           <a:solidFill>
                             <a:srgbClr val="1E1E1E"/>
                           </a:solidFill>
@@ -16657,7 +18653,7 @@
                     <a:p>
                       <a:pPr algn="l"/>
                       <a:r>
-                        <a:rPr sz="1100" b="0">
+                        <a:rPr sz="1050" b="0">
                           <a:solidFill>
                             <a:srgbClr val="1E1E1E"/>
                           </a:solidFill>
@@ -16680,7 +18676,7 @@
                     <a:p>
                       <a:pPr algn="l"/>
                       <a:r>
-                        <a:rPr sz="1100" b="0">
+                        <a:rPr sz="1050" b="0">
                           <a:solidFill>
                             <a:srgbClr val="1E1E1E"/>
                           </a:solidFill>
@@ -16703,7 +18699,7 @@
                     <a:p>
                       <a:pPr algn="l"/>
                       <a:r>
-                        <a:rPr sz="1100" b="0">
+                        <a:rPr sz="1050" b="0">
                           <a:solidFill>
                             <a:srgbClr val="1E1E1E"/>
                           </a:solidFill>
@@ -16726,7 +18722,7 @@
                     <a:p>
                       <a:pPr algn="l"/>
                       <a:r>
-                        <a:rPr sz="1100" b="0">
+                        <a:rPr sz="1050" b="0">
                           <a:solidFill>
                             <a:srgbClr val="1E1E1E"/>
                           </a:solidFill>
@@ -16751,7 +18747,7 @@
                     <a:p>
                       <a:pPr algn="l"/>
                       <a:r>
-                        <a:rPr sz="1100" b="0">
+                        <a:rPr sz="1050" b="0">
                           <a:solidFill>
                             <a:srgbClr val="1E1E1E"/>
                           </a:solidFill>
@@ -16774,7 +18770,7 @@
                     <a:p>
                       <a:pPr algn="l"/>
                       <a:r>
-                        <a:rPr sz="1100" b="0">
+                        <a:rPr sz="1050" b="0">
                           <a:solidFill>
                             <a:srgbClr val="1E1E1E"/>
                           </a:solidFill>
@@ -16797,7 +18793,7 @@
                     <a:p>
                       <a:pPr algn="l"/>
                       <a:r>
-                        <a:rPr sz="1100" b="0">
+                        <a:rPr sz="1050" b="0">
                           <a:solidFill>
                             <a:srgbClr val="1E1E1E"/>
                           </a:solidFill>
@@ -16820,7 +18816,7 @@
                     <a:p>
                       <a:pPr algn="l"/>
                       <a:r>
-                        <a:rPr sz="1100" b="0">
+                        <a:rPr sz="1050" b="0">
                           <a:solidFill>
                             <a:srgbClr val="1E1E1E"/>
                           </a:solidFill>
@@ -16843,7 +18839,7 @@
                     <a:p>
                       <a:pPr algn="l"/>
                       <a:r>
-                        <a:rPr sz="1100" b="0">
+                        <a:rPr sz="1050" b="0">
                           <a:solidFill>
                             <a:srgbClr val="1E1E1E"/>
                           </a:solidFill>
@@ -16868,7 +18864,7 @@
                     <a:p>
                       <a:pPr algn="l"/>
                       <a:r>
-                        <a:rPr sz="1100" b="0">
+                        <a:rPr sz="1050" b="0">
                           <a:solidFill>
                             <a:srgbClr val="1E1E1E"/>
                           </a:solidFill>
@@ -16891,7 +18887,7 @@
                     <a:p>
                       <a:pPr algn="l"/>
                       <a:r>
-                        <a:rPr sz="1100" b="0">
+                        <a:rPr sz="1050" b="0">
                           <a:solidFill>
                             <a:srgbClr val="1E1E1E"/>
                           </a:solidFill>
@@ -16914,7 +18910,7 @@
                     <a:p>
                       <a:pPr algn="l"/>
                       <a:r>
-                        <a:rPr sz="1100" b="0">
+                        <a:rPr sz="1050" b="0">
                           <a:solidFill>
                             <a:srgbClr val="1E1E1E"/>
                           </a:solidFill>
@@ -16937,7 +18933,7 @@
                     <a:p>
                       <a:pPr algn="l"/>
                       <a:r>
-                        <a:rPr sz="1100" b="0">
+                        <a:rPr sz="1050" b="0">
                           <a:solidFill>
                             <a:srgbClr val="1E1E1E"/>
                           </a:solidFill>
@@ -16960,7 +18956,7 @@
                     <a:p>
                       <a:pPr algn="l"/>
                       <a:r>
-                        <a:rPr sz="1100" b="0">
+                        <a:rPr sz="1050" b="0">
                           <a:solidFill>
                             <a:srgbClr val="1E1E1E"/>
                           </a:solidFill>
@@ -16985,7 +18981,7 @@
                     <a:p>
                       <a:pPr algn="l"/>
                       <a:r>
-                        <a:rPr sz="1100" b="0">
+                        <a:rPr sz="1050" b="0">
                           <a:solidFill>
                             <a:srgbClr val="1E1E1E"/>
                           </a:solidFill>
@@ -17008,7 +19004,7 @@
                     <a:p>
                       <a:pPr algn="l"/>
                       <a:r>
-                        <a:rPr sz="1100" b="0">
+                        <a:rPr sz="1050" b="0">
                           <a:solidFill>
                             <a:srgbClr val="1E1E1E"/>
                           </a:solidFill>
@@ -17031,7 +19027,7 @@
                     <a:p>
                       <a:pPr algn="l"/>
                       <a:r>
-                        <a:rPr sz="1100" b="0">
+                        <a:rPr sz="1050" b="0">
                           <a:solidFill>
                             <a:srgbClr val="1E1E1E"/>
                           </a:solidFill>
@@ -17054,7 +19050,7 @@
                     <a:p>
                       <a:pPr algn="l"/>
                       <a:r>
-                        <a:rPr sz="1100" b="0">
+                        <a:rPr sz="1050" b="0">
                           <a:solidFill>
                             <a:srgbClr val="1E1E1E"/>
                           </a:solidFill>
@@ -17077,7 +19073,7 @@
                     <a:p>
                       <a:pPr algn="l"/>
                       <a:r>
-                        <a:rPr sz="1100" b="0">
+                        <a:rPr sz="1050" b="0">
                           <a:solidFill>
                             <a:srgbClr val="1E1E1E"/>
                           </a:solidFill>
@@ -17102,7 +19098,7 @@
                     <a:p>
                       <a:pPr algn="l"/>
                       <a:r>
-                        <a:rPr sz="1100" b="0">
+                        <a:rPr sz="1050" b="0">
                           <a:solidFill>
                             <a:srgbClr val="1E1E1E"/>
                           </a:solidFill>
@@ -17125,7 +19121,7 @@
                     <a:p>
                       <a:pPr algn="l"/>
                       <a:r>
-                        <a:rPr sz="1100" b="0">
+                        <a:rPr sz="1050" b="0">
                           <a:solidFill>
                             <a:srgbClr val="1E1E1E"/>
                           </a:solidFill>
@@ -17148,7 +19144,7 @@
                     <a:p>
                       <a:pPr algn="l"/>
                       <a:r>
-                        <a:rPr sz="1100" b="0">
+                        <a:rPr sz="1050" b="0">
                           <a:solidFill>
                             <a:srgbClr val="1E1E1E"/>
                           </a:solidFill>
@@ -17171,7 +19167,7 @@
                     <a:p>
                       <a:pPr algn="l"/>
                       <a:r>
-                        <a:rPr sz="1100" b="0">
+                        <a:rPr sz="1050" b="0">
                           <a:solidFill>
                             <a:srgbClr val="1E1E1E"/>
                           </a:solidFill>
@@ -17194,7 +19190,7 @@
                     <a:p>
                       <a:pPr algn="l"/>
                       <a:r>
-                        <a:rPr sz="1100" b="0">
+                        <a:rPr sz="1050" b="0">
                           <a:solidFill>
                             <a:srgbClr val="1E1E1E"/>
                           </a:solidFill>

</xml_diff>